<commit_message>
Presentation: add slides for the per-packet pipeline, dataset campaign and KPI result
Append three slides (11-13) to the participant deck, keeping all originals:
- 11 Scale up - generate a reproducible dataset (lab.sh + generate_final.sh)
- 12 Train and evaluate the per-packet detector (build_mixed_windows / train_model
  --arch perpacket / evaluate_compare, and run_final_pipeline.sh)
- 13 Result - per-packet CNN meets the NATWORK KPIs (FP 0.0001%, FN 0.009%)
</commit_message>
<xml_diff>
--- a/6G-DALI_NATWORK_Hackathon_Presentation_Final.pptx
+++ b/6G-DALI_NATWORK_Hackathon_Presentation_Final.pptx
@@ -18,6 +18,9 @@
     <p:sldId id="263" r:id="rId11"/>
     <p:sldId id="264" r:id="rId12"/>
     <p:sldId id="265" r:id="rId13"/>
+    <p:sldId id="266" r:id="rId15"/>
+    <p:sldId id="267" r:id="rId16"/>
+    <p:sldId id="268" r:id="rId17"/>
   </p:sldIdLst>
   <p:sldSz cx="12192000" cy="6858000"/>
   <p:notesSz cx="6858000" cy="12192000"/>
@@ -4481,6 +4484,3114 @@
               <a:t>Raw PCAP support is not confirmed by the integration guide; coordinate accepted submission format with organizers.</a:t>
             </a:r>
             <a:endParaRPr b="0" lang="en-US" sz="1200" strike="noStrike" u="none">
+              <a:solidFill>
+                <a:srgbClr val="000000"/>
+              </a:solidFill>
+              <a:effectLst/>
+              <a:uFillTx/>
+              <a:latin typeface="Arial"/>
+            </a:endParaRPr>
+          </a:p>
+        </p:txBody>
+      </p:sp>
+    </p:spTree>
+  </p:cSld>
+  <mc:AlternateContent>
+    <mc:Choice Requires="p14">
+      <p:transition spd="slow" p14:dur="2000"/>
+    </mc:Choice>
+    <mc:Fallback>
+      <p:transition spd="slow"/>
+    </mc:Fallback>
+  </mc:AlternateContent>
+</p:sld>
+</file>
+
+<file path=ppt/slides/slide11.xml><?xml version="1.0" encoding="utf-8"?>
+<p:sld xmlns:a="http://schemas.openxmlformats.org/drawingml/2006/main" xmlns:p="http://schemas.openxmlformats.org/presentationml/2006/main" xmlns:r="http://schemas.openxmlformats.org/officeDocument/2006/relationships" xmlns:p14="http://schemas.microsoft.com/office/powerpoint/2010/main" xmlns:p15="http://schemas.microsoft.com/office/powerpoint/2012/main" xmlns:mc="http://schemas.openxmlformats.org/markup-compatibility/2006">
+  <p:cSld>
+    <p:bg>
+      <p:bgPr>
+        <a:solidFill>
+          <a:srgbClr val="ffffff"/>
+        </a:solidFill>
+      </p:bgPr>
+    </p:bg>
+    <p:spTree>
+      <p:nvGrpSpPr>
+        <p:cNvPr id="1" name=""/>
+        <p:cNvGrpSpPr/>
+        <p:nvPr/>
+      </p:nvGrpSpPr>
+      <p:grpSpPr>
+        <a:xfrm>
+          <a:off x="0" y="0"/>
+          <a:ext cx="0" cy="0"/>
+          <a:chOff x="0" y="0"/>
+          <a:chExt cx="0" cy="0"/>
+        </a:xfrm>
+      </p:grpSpPr>
+      <p:sp>
+        <p:nvSpPr>
+          <p:cNvPr id="135" name="Shape 0"/>
+          <p:cNvSpPr/>
+          <p:nvPr/>
+        </p:nvSpPr>
+        <p:spPr>
+          <a:xfrm>
+            <a:off x="0" y="0"/>
+            <a:ext cx="12191400" cy="109440"/>
+          </a:xfrm>
+          <a:prstGeom prst="rect">
+            <a:avLst/>
+          </a:prstGeom>
+          <a:solidFill>
+            <a:srgbClr val="ee791f"/>
+          </a:solidFill>
+          <a:ln w="12700">
+            <a:solidFill>
+              <a:srgbClr val="ee791f"/>
+            </a:solidFill>
+            <a:round/>
+          </a:ln>
+        </p:spPr>
+        <p:style>
+          <a:lnRef idx="0"/>
+          <a:fillRef idx="0"/>
+          <a:effectRef idx="0"/>
+          <a:fontRef idx="minor"/>
+        </p:style>
+        <p:txBody>
+          <a:bodyPr lIns="90000" rIns="90000" tIns="45000" bIns="45000" anchor="t">
+            <a:noAutofit/>
+          </a:bodyPr>
+          <a:p>
+            <a:endParaRPr b="0" lang="en-US" sz="1800" strike="noStrike" u="none">
+              <a:solidFill>
+                <a:srgbClr val="ffffff"/>
+              </a:solidFill>
+              <a:effectLst/>
+              <a:uFillTx/>
+              <a:latin typeface="Arial"/>
+            </a:endParaRPr>
+          </a:p>
+        </p:txBody>
+      </p:sp>
+      <p:sp>
+        <p:nvSpPr>
+          <p:cNvPr id="136" name="Text 1"/>
+          <p:cNvSpPr/>
+          <p:nvPr/>
+        </p:nvSpPr>
+        <p:spPr>
+          <a:xfrm>
+            <a:off x="530280" y="311040"/>
+            <a:ext cx="10881000" cy="548280"/>
+          </a:xfrm>
+          <a:prstGeom prst="rect">
+            <a:avLst/>
+          </a:prstGeom>
+          <a:noFill/>
+          <a:ln w="0">
+            <a:noFill/>
+          </a:ln>
+        </p:spPr>
+        <p:style>
+          <a:lnRef idx="0"/>
+          <a:fillRef idx="0"/>
+          <a:effectRef idx="0"/>
+          <a:fontRef idx="minor"/>
+        </p:style>
+        <p:txBody>
+          <a:bodyPr lIns="360" rIns="360" tIns="360" bIns="360" anchor="ctr">
+            <a:normAutofit/>
+          </a:bodyPr>
+          <a:p>
+            <a:pPr defTabSz="914400">
+              <a:lnSpc>
+                <a:spcPct val="100000"/>
+              </a:lnSpc>
+              <a:tabLst>
+                <a:tab algn="l" pos="0"/>
+              </a:tabLst>
+            </a:pPr>
+            <a:r>
+              <a:rPr b="1" lang="en-US" sz="2700" strike="noStrike" u="none">
+                <a:solidFill>
+                  <a:srgbClr val="11233b"/>
+                </a:solidFill>
+                <a:effectLst/>
+                <a:uFillTx/>
+                <a:latin typeface="Aptos"/>
+                <a:ea typeface="Aptos"/>
+              </a:rPr>
+              <a:t>Scale up — generate a reproducible dataset</a:t>
+            </a:r>
+            <a:endParaRPr b="0" lang="en-US" sz="2700" strike="noStrike" u="none">
+              <a:solidFill>
+                <a:srgbClr val="000000"/>
+              </a:solidFill>
+              <a:effectLst/>
+              <a:uFillTx/>
+              <a:latin typeface="Arial"/>
+            </a:endParaRPr>
+          </a:p>
+        </p:txBody>
+      </p:sp>
+      <p:sp>
+        <p:nvSpPr>
+          <p:cNvPr id="137" name="Shape 2"/>
+          <p:cNvSpPr/>
+          <p:nvPr/>
+        </p:nvSpPr>
+        <p:spPr>
+          <a:xfrm>
+            <a:off x="530280" y="951120"/>
+            <a:ext cx="11100600" cy="31680"/>
+          </a:xfrm>
+          <a:prstGeom prst="rect">
+            <a:avLst/>
+          </a:prstGeom>
+          <a:solidFill>
+            <a:srgbClr val="ee791f"/>
+          </a:solidFill>
+          <a:ln w="12700">
+            <a:solidFill>
+              <a:srgbClr val="ee791f"/>
+            </a:solidFill>
+            <a:round/>
+          </a:ln>
+        </p:spPr>
+        <p:style>
+          <a:lnRef idx="0"/>
+          <a:fillRef idx="0"/>
+          <a:effectRef idx="0"/>
+          <a:fontRef idx="minor"/>
+        </p:style>
+        <p:txBody>
+          <a:bodyPr lIns="90000" rIns="90000" tIns="-12960" bIns="-12960" anchor="t">
+            <a:noAutofit/>
+          </a:bodyPr>
+          <a:p>
+            <a:endParaRPr b="0" lang="en-US" sz="1800" strike="noStrike" u="none">
+              <a:solidFill>
+                <a:srgbClr val="ffffff"/>
+              </a:solidFill>
+              <a:effectLst/>
+              <a:uFillTx/>
+              <a:latin typeface="Arial"/>
+            </a:endParaRPr>
+          </a:p>
+        </p:txBody>
+      </p:sp>
+      <p:sp>
+        <p:nvSpPr>
+          <p:cNvPr id="138" name="Text 3"/>
+          <p:cNvSpPr/>
+          <p:nvPr/>
+        </p:nvSpPr>
+        <p:spPr>
+          <a:xfrm>
+            <a:off x="548640" y="6473880"/>
+            <a:ext cx="9143640" cy="200880"/>
+          </a:xfrm>
+          <a:prstGeom prst="rect">
+            <a:avLst/>
+          </a:prstGeom>
+          <a:noFill/>
+          <a:ln w="0">
+            <a:noFill/>
+          </a:ln>
+        </p:spPr>
+        <p:style>
+          <a:lnRef idx="0"/>
+          <a:fillRef idx="0"/>
+          <a:effectRef idx="0"/>
+          <a:fontRef idx="minor"/>
+        </p:style>
+        <p:txBody>
+          <a:bodyPr lIns="360" rIns="360" tIns="360" bIns="360" anchor="ctr">
+            <a:normAutofit/>
+          </a:bodyPr>
+          <a:p>
+            <a:pPr defTabSz="914400">
+              <a:lnSpc>
+                <a:spcPct val="100000"/>
+              </a:lnSpc>
+              <a:tabLst>
+                <a:tab algn="l" pos="0"/>
+              </a:tabLst>
+            </a:pPr>
+            <a:r>
+              <a:rPr b="0" lang="en-US" sz="900" strike="noStrike" u="none">
+                <a:solidFill>
+                  <a:srgbClr val="586a79"/>
+                </a:solidFill>
+                <a:effectLst/>
+                <a:uFillTx/>
+                <a:latin typeface="Aptos"/>
+                <a:ea typeface="Aptos"/>
+              </a:rPr>
+              <a:t>6G-DALI  ×  NATWORK  |  LOCAL CYBERSECURITY HACKATHON</a:t>
+            </a:r>
+            <a:endParaRPr b="0" lang="en-US" sz="900" strike="noStrike" u="none">
+              <a:solidFill>
+                <a:srgbClr val="000000"/>
+              </a:solidFill>
+              <a:effectLst/>
+              <a:uFillTx/>
+              <a:latin typeface="Arial"/>
+            </a:endParaRPr>
+          </a:p>
+        </p:txBody>
+      </p:sp>
+      <p:sp>
+        <p:nvSpPr>
+          <p:cNvPr id="139" name="Text 4"/>
+          <p:cNvSpPr/>
+          <p:nvPr/>
+        </p:nvSpPr>
+        <p:spPr>
+          <a:xfrm>
+            <a:off x="11018520" y="6473880"/>
+            <a:ext cx="511560" cy="200880"/>
+          </a:xfrm>
+          <a:prstGeom prst="rect">
+            <a:avLst/>
+          </a:prstGeom>
+          <a:noFill/>
+          <a:ln w="0">
+            <a:noFill/>
+          </a:ln>
+        </p:spPr>
+        <p:style>
+          <a:lnRef idx="0"/>
+          <a:fillRef idx="0"/>
+          <a:effectRef idx="0"/>
+          <a:fontRef idx="minor"/>
+        </p:style>
+        <p:txBody>
+          <a:bodyPr lIns="360" rIns="360" tIns="360" bIns="360" anchor="ctr">
+            <a:normAutofit/>
+          </a:bodyPr>
+          <a:p>
+            <a:pPr algn="r" defTabSz="914400">
+              <a:lnSpc>
+                <a:spcPct val="100000"/>
+              </a:lnSpc>
+              <a:tabLst>
+                <a:tab algn="l" pos="0"/>
+              </a:tabLst>
+            </a:pPr>
+            <a:r>
+              <a:rPr b="0" lang="en-US" sz="900" strike="noStrike" u="none">
+                <a:solidFill>
+                  <a:srgbClr val="586a79"/>
+                </a:solidFill>
+                <a:effectLst/>
+                <a:uFillTx/>
+                <a:latin typeface="Aptos"/>
+                <a:ea typeface="Aptos"/>
+              </a:rPr>
+              <a:t>11</a:t>
+            </a:r>
+            <a:endParaRPr b="0" lang="en-US" sz="900" strike="noStrike" u="none">
+              <a:solidFill>
+                <a:srgbClr val="000000"/>
+              </a:solidFill>
+              <a:effectLst/>
+              <a:uFillTx/>
+              <a:latin typeface="Arial"/>
+            </a:endParaRPr>
+          </a:p>
+        </p:txBody>
+      </p:sp>
+      <p:sp>
+        <p:nvSpPr>
+          <p:cNvPr id="140" name="Shape 5"/>
+          <p:cNvSpPr/>
+          <p:nvPr/>
+        </p:nvSpPr>
+        <p:spPr>
+          <a:xfrm>
+            <a:off x="612720" y="1271160"/>
+            <a:ext cx="7086240" cy="4361400"/>
+          </a:xfrm>
+          <a:prstGeom prst="roundRect">
+            <a:avLst>
+              <a:gd name="adj" fmla="val 2096"/>
+            </a:avLst>
+          </a:prstGeom>
+          <a:solidFill>
+            <a:srgbClr val="11233b"/>
+          </a:solidFill>
+          <a:ln w="12700">
+            <a:solidFill>
+              <a:srgbClr val="11233b"/>
+            </a:solidFill>
+            <a:round/>
+          </a:ln>
+        </p:spPr>
+        <p:style>
+          <a:lnRef idx="0"/>
+          <a:fillRef idx="0"/>
+          <a:effectRef idx="0"/>
+          <a:fontRef idx="minor"/>
+        </p:style>
+        <p:txBody>
+          <a:bodyPr lIns="90000" rIns="90000" tIns="45000" bIns="45000" anchor="t">
+            <a:noAutofit/>
+          </a:bodyPr>
+          <a:p>
+            <a:endParaRPr b="0" lang="en-US" sz="1800" strike="noStrike" u="none">
+              <a:solidFill>
+                <a:srgbClr val="ffffff"/>
+              </a:solidFill>
+              <a:effectLst/>
+              <a:uFillTx/>
+              <a:latin typeface="Arial"/>
+            </a:endParaRPr>
+          </a:p>
+        </p:txBody>
+      </p:sp>
+      <p:sp>
+        <p:nvSpPr>
+          <p:cNvPr id="141" name="Text 6"/>
+          <p:cNvSpPr/>
+          <p:nvPr/>
+        </p:nvSpPr>
+        <p:spPr>
+          <a:xfrm>
+            <a:off x="795600" y="1380600"/>
+            <a:ext cx="6738840" cy="4178520"/>
+          </a:xfrm>
+          <a:prstGeom prst="rect">
+            <a:avLst/>
+          </a:prstGeom>
+          <a:noFill/>
+          <a:ln w="0">
+            <a:noFill/>
+          </a:ln>
+        </p:spPr>
+        <p:style>
+          <a:lnRef idx="0"/>
+          <a:fillRef idx="0"/>
+          <a:effectRef idx="0"/>
+          <a:fontRef idx="minor"/>
+        </p:style>
+        <p:txBody>
+          <a:bodyPr lIns="360" rIns="360" tIns="360" bIns="360" anchor="t">
+            <a:normAutofit/>
+          </a:bodyPr>
+          <a:p>
+            <a:pPr defTabSz="914400">
+              <a:lnSpc>
+                <a:spcPct val="100000"/>
+              </a:lnSpc>
+              <a:tabLst>
+                <a:tab algn="l" pos="0"/>
+              </a:tabLst>
+            </a:pPr>
+            <a:r>
+              <a:rPr b="0" lang="en-US" sz="1300" strike="noStrike" u="none">
+                <a:solidFill>
+                  <a:srgbClr val="e9f5fc"/>
+                </a:solidFill>
+                <a:effectLst/>
+                <a:uFillTx/>
+                <a:latin typeface="Aptos Mono"/>
+                <a:ea typeface="Aptos Mono"/>
+              </a:rPr>
+              <a:t>cd infrastructure</a:t>
+            </a:r>
+            <a:endParaRPr b="0" lang="en-US" sz="1300" strike="noStrike" u="none">
+              <a:solidFill>
+                <a:srgbClr val="000000"/>
+              </a:solidFill>
+              <a:effectLst/>
+              <a:uFillTx/>
+              <a:latin typeface="Arial"/>
+            </a:endParaRPr>
+          </a:p>
+          <a:p>
+            <a:pPr defTabSz="914400">
+              <a:lnSpc>
+                <a:spcPct val="100000"/>
+              </a:lnSpc>
+              <a:tabLst>
+                <a:tab algn="l" pos="0"/>
+              </a:tabLst>
+            </a:pPr>
+            <a:r>
+              <a:rPr b="0" lang="en-US" sz="1300" strike="noStrike" u="none">
+                <a:solidFill>
+                  <a:srgbClr val="e9f5fc"/>
+                </a:solidFill>
+                <a:effectLst/>
+                <a:uFillTx/>
+                <a:latin typeface="Aptos Mono"/>
+                <a:ea typeface="Aptos Mono"/>
+              </a:rPr>
+              <a:t>./lab.sh up          # patched lab (Mirai + uplink fix)</a:t>
+            </a:r>
+            <a:endParaRPr b="0" lang="en-US" sz="1300" strike="noStrike" u="none">
+              <a:solidFill>
+                <a:srgbClr val="000000"/>
+              </a:solidFill>
+              <a:effectLst/>
+              <a:uFillTx/>
+              <a:latin typeface="Arial"/>
+            </a:endParaRPr>
+          </a:p>
+          <a:p>
+            <a:pPr defTabSz="914400">
+              <a:lnSpc>
+                <a:spcPct val="100000"/>
+              </a:lnSpc>
+              <a:tabLst>
+                <a:tab algn="l" pos="0"/>
+              </a:tabLst>
+            </a:pPr>
+            <a:r>
+              <a:rPr b="0" lang="en-US" sz="1300" strike="noStrike" u="none">
+                <a:solidFill>
+                  <a:srgbClr val="e9f5fc"/>
+                </a:solidFill>
+                <a:effectLst/>
+                <a:uFillTx/>
+                <a:latin typeface="Aptos Mono"/>
+                <a:ea typeface="Aptos Mono"/>
+              </a:rPr>
+              <a:t>./lab.sh status      # wait: UE 10.45.0.2, bot on :23</a:t>
+            </a:r>
+            <a:endParaRPr b="0" lang="en-US" sz="1300" strike="noStrike" u="none">
+              <a:solidFill>
+                <a:srgbClr val="000000"/>
+              </a:solidFill>
+              <a:effectLst/>
+              <a:uFillTx/>
+              <a:latin typeface="Arial"/>
+            </a:endParaRPr>
+          </a:p>
+          <a:p>
+            <a:pPr defTabSz="914400">
+              <a:lnSpc>
+                <a:spcPct val="100000"/>
+              </a:lnSpc>
+              <a:tabLst>
+                <a:tab algn="l" pos="0"/>
+              </a:tabLst>
+            </a:pPr>
+            <a:r>
+              <a:rPr b="0" lang="en-US" sz="1300" strike="noStrike" u="none">
+                <a:solidFill>
+                  <a:srgbClr val="e9f5fc"/>
+                </a:solidFill>
+                <a:effectLst/>
+                <a:uFillTx/>
+                <a:latin typeface="Aptos Mono"/>
+                <a:ea typeface="Aptos Mono"/>
+              </a:rPr>
+              <a:t># capture benign + Mirai together, one pass:</a:t>
+            </a:r>
+            <a:endParaRPr b="0" lang="en-US" sz="1300" strike="noStrike" u="none">
+              <a:solidFill>
+                <a:srgbClr val="000000"/>
+              </a:solidFill>
+              <a:effectLst/>
+              <a:uFillTx/>
+              <a:latin typeface="Arial"/>
+            </a:endParaRPr>
+          </a:p>
+          <a:p>
+            <a:pPr defTabSz="914400">
+              <a:lnSpc>
+                <a:spcPct val="100000"/>
+              </a:lnSpc>
+              <a:tabLst>
+                <a:tab algn="l" pos="0"/>
+              </a:tabLst>
+            </a:pPr>
+            <a:r>
+              <a:rPr b="0" lang="en-US" sz="1300" strike="noStrike" u="none">
+                <a:solidFill>
+                  <a:srgbClr val="e9f5fc"/>
+                </a:solidFill>
+                <a:effectLst/>
+                <a:uFillTx/>
+                <a:latin typeface="Aptos Mono"/>
+                <a:ea typeface="Aptos Mono"/>
+              </a:rPr>
+              <a:t>../datasets/generate_final.sh big 15 60</a:t>
+            </a:r>
+            <a:endParaRPr b="0" lang="en-US" sz="1300" strike="noStrike" u="none">
+              <a:solidFill>
+                <a:srgbClr val="000000"/>
+              </a:solidFill>
+              <a:effectLst/>
+              <a:uFillTx/>
+              <a:latin typeface="Arial"/>
+            </a:endParaRPr>
+          </a:p>
+          <a:p>
+            <a:pPr defTabSz="914400">
+              <a:lnSpc>
+                <a:spcPct val="100000"/>
+              </a:lnSpc>
+              <a:tabLst>
+                <a:tab algn="l" pos="0"/>
+              </a:tabLst>
+            </a:pPr>
+            <a:r>
+              <a:rPr b="0" lang="en-US" sz="1300" strike="noStrike" u="none">
+                <a:solidFill>
+                  <a:srgbClr val="e9f5fc"/>
+                </a:solidFill>
+                <a:effectLst/>
+                <a:uFillTx/>
+                <a:latin typeface="Aptos Mono"/>
+                <a:ea typeface="Aptos Mono"/>
+              </a:rPr>
+              <a:t># -&gt; datasets/pcap_big/  (~15 GB, snaplen 128)</a:t>
+            </a:r>
+            <a:endParaRPr b="0" lang="en-US" sz="1300" strike="noStrike" u="none">
+              <a:solidFill>
+                <a:srgbClr val="000000"/>
+              </a:solidFill>
+              <a:effectLst/>
+              <a:uFillTx/>
+              <a:latin typeface="Arial"/>
+            </a:endParaRPr>
+          </a:p>
+          <a:p>
+            <a:pPr defTabSz="914400">
+              <a:lnSpc>
+                <a:spcPct val="100000"/>
+              </a:lnSpc>
+              <a:tabLst>
+                <a:tab algn="l" pos="0"/>
+              </a:tabLst>
+            </a:pPr>
+            <a:r>
+              <a:rPr b="0" lang="en-US" sz="1300" strike="noStrike" u="none">
+                <a:solidFill>
+                  <a:srgbClr val="e9f5fc"/>
+                </a:solidFill>
+                <a:effectLst/>
+                <a:uFillTx/>
+                <a:latin typeface="Aptos Mono"/>
+                <a:ea typeface="Aptos Mono"/>
+              </a:rPr>
+              <a:t>ls -lh ../datasets/pcap_big/</a:t>
+            </a:r>
+            <a:endParaRPr b="0" lang="en-US" sz="1300" strike="noStrike" u="none">
+              <a:solidFill>
+                <a:srgbClr val="000000"/>
+              </a:solidFill>
+              <a:effectLst/>
+              <a:uFillTx/>
+              <a:latin typeface="Arial"/>
+            </a:endParaRPr>
+          </a:p>
+          <a:p>
+            <a:pPr defTabSz="914400">
+              <a:lnSpc>
+                <a:spcPct val="100000"/>
+              </a:lnSpc>
+              <a:tabLst>
+                <a:tab algn="l" pos="0"/>
+              </a:tabLst>
+            </a:pPr>
+            <a:r>
+              <a:rPr b="0" lang="en-US" sz="1300" strike="noStrike" u="none">
+                <a:solidFill>
+                  <a:srgbClr val="e9f5fc"/>
+                </a:solidFill>
+                <a:effectLst/>
+                <a:uFillTx/>
+                <a:latin typeface="Aptos Mono"/>
+                <a:ea typeface="Aptos Mono"/>
+              </a:rPr>
+              <a:t># alternatives:</a:t>
+            </a:r>
+            <a:endParaRPr b="0" lang="en-US" sz="1300" strike="noStrike" u="none">
+              <a:solidFill>
+                <a:srgbClr val="000000"/>
+              </a:solidFill>
+              <a:effectLst/>
+              <a:uFillTx/>
+              <a:latin typeface="Arial"/>
+            </a:endParaRPr>
+          </a:p>
+          <a:p>
+            <a:pPr defTabSz="914400">
+              <a:lnSpc>
+                <a:spcPct val="100000"/>
+              </a:lnSpc>
+              <a:tabLst>
+                <a:tab algn="l" pos="0"/>
+              </a:tabLst>
+            </a:pPr>
+            <a:r>
+              <a:rPr b="0" lang="en-US" sz="1300" strike="noStrike" u="none">
+                <a:solidFill>
+                  <a:srgbClr val="e9f5fc"/>
+                </a:solidFill>
+                <a:effectLst/>
+                <a:uFillTx/>
+                <a:latin typeface="Aptos Mono"/>
+                <a:ea typeface="Aptos Mono"/>
+              </a:rPr>
+              <a:t>#   generate_m.sh  ·  capture_attack.sh + capture_benign.sh</a:t>
+            </a:r>
+            <a:endParaRPr b="0" lang="en-US" sz="1300" strike="noStrike" u="none">
+              <a:solidFill>
+                <a:srgbClr val="000000"/>
+              </a:solidFill>
+              <a:effectLst/>
+              <a:uFillTx/>
+              <a:latin typeface="Arial"/>
+            </a:endParaRPr>
+          </a:p>
+        </p:txBody>
+      </p:sp>
+      <p:sp>
+        <p:nvSpPr>
+          <p:cNvPr id="142" name="Shape 7"/>
+          <p:cNvSpPr/>
+          <p:nvPr/>
+        </p:nvSpPr>
+        <p:spPr>
+          <a:xfrm>
+            <a:off x="8010000" y="1271160"/>
+            <a:ext cx="3501720" cy="4379760"/>
+          </a:xfrm>
+          <a:prstGeom prst="roundRect">
+            <a:avLst>
+              <a:gd name="adj" fmla="val 2611"/>
+            </a:avLst>
+          </a:prstGeom>
+          <a:solidFill>
+            <a:srgbClr val="f2f6fa"/>
+          </a:solidFill>
+          <a:ln w="12700">
+            <a:solidFill>
+              <a:srgbClr val="f2f6fa"/>
+            </a:solidFill>
+            <a:round/>
+          </a:ln>
+        </p:spPr>
+        <p:style>
+          <a:lnRef idx="0"/>
+          <a:fillRef idx="0"/>
+          <a:effectRef idx="0"/>
+          <a:fontRef idx="minor"/>
+        </p:style>
+        <p:txBody>
+          <a:bodyPr lIns="90000" rIns="90000" tIns="45000" bIns="45000" anchor="t">
+            <a:noAutofit/>
+          </a:bodyPr>
+          <a:p>
+            <a:endParaRPr b="0" lang="en-US" sz="1800" strike="noStrike" u="none">
+              <a:solidFill>
+                <a:srgbClr val="000000"/>
+              </a:solidFill>
+              <a:effectLst/>
+              <a:uFillTx/>
+              <a:latin typeface="Arial"/>
+            </a:endParaRPr>
+          </a:p>
+        </p:txBody>
+      </p:sp>
+      <p:sp>
+        <p:nvSpPr>
+          <p:cNvPr id="143" name="Text 8"/>
+          <p:cNvSpPr/>
+          <p:nvPr/>
+        </p:nvSpPr>
+        <p:spPr>
+          <a:xfrm>
+            <a:off x="8275320" y="1508760"/>
+            <a:ext cx="2880000" cy="411120"/>
+          </a:xfrm>
+          <a:prstGeom prst="rect">
+            <a:avLst/>
+          </a:prstGeom>
+          <a:noFill/>
+          <a:ln w="0">
+            <a:noFill/>
+          </a:ln>
+        </p:spPr>
+        <p:style>
+          <a:lnRef idx="0"/>
+          <a:fillRef idx="0"/>
+          <a:effectRef idx="0"/>
+          <a:fontRef idx="minor"/>
+        </p:style>
+        <p:txBody>
+          <a:bodyPr lIns="360" rIns="360" tIns="360" bIns="360" anchor="ctr">
+            <a:normAutofit/>
+          </a:bodyPr>
+          <a:p>
+            <a:pPr defTabSz="914400">
+              <a:lnSpc>
+                <a:spcPct val="100000"/>
+              </a:lnSpc>
+              <a:tabLst>
+                <a:tab algn="l" pos="0"/>
+              </a:tabLst>
+            </a:pPr>
+            <a:r>
+              <a:rPr b="1" lang="en-US" sz="1900" strike="noStrike" u="none">
+                <a:solidFill>
+                  <a:srgbClr val="22618a"/>
+                </a:solidFill>
+                <a:effectLst/>
+                <a:uFillTx/>
+                <a:latin typeface="Aptos"/>
+                <a:ea typeface="Aptos"/>
+              </a:rPr>
+              <a:t>Realistic by design</a:t>
+            </a:r>
+            <a:endParaRPr b="0" lang="en-US" sz="1900" strike="noStrike" u="none">
+              <a:solidFill>
+                <a:srgbClr val="000000"/>
+              </a:solidFill>
+              <a:effectLst/>
+              <a:uFillTx/>
+              <a:latin typeface="Arial"/>
+            </a:endParaRPr>
+          </a:p>
+        </p:txBody>
+      </p:sp>
+      <p:sp>
+        <p:nvSpPr>
+          <p:cNvPr id="144" name="Text 9"/>
+          <p:cNvSpPr/>
+          <p:nvPr/>
+        </p:nvSpPr>
+        <p:spPr>
+          <a:xfrm>
+            <a:off x="8284320" y="2066400"/>
+            <a:ext cx="2898360" cy="3135960"/>
+          </a:xfrm>
+          <a:prstGeom prst="rect">
+            <a:avLst/>
+          </a:prstGeom>
+          <a:noFill/>
+          <a:ln w="0">
+            <a:noFill/>
+          </a:ln>
+        </p:spPr>
+        <p:style>
+          <a:lnRef idx="0"/>
+          <a:fillRef idx="0"/>
+          <a:effectRef idx="0"/>
+          <a:fontRef idx="minor"/>
+        </p:style>
+        <p:txBody>
+          <a:bodyPr lIns="360" rIns="360" tIns="360" bIns="360" anchor="ctr">
+            <a:normAutofit lnSpcReduction="9999"/>
+          </a:bodyPr>
+          <a:p>
+            <a:pPr defTabSz="914400">
+              <a:lnSpc>
+                <a:spcPct val="100000"/>
+              </a:lnSpc>
+              <a:tabLst>
+                <a:tab algn="l" pos="0"/>
+              </a:tabLst>
+            </a:pPr>
+            <a:r>
+              <a:rPr b="0" lang="en-US" sz="1600" strike="noStrike" u="none">
+                <a:solidFill>
+                  <a:srgbClr val="11233b"/>
+                </a:solidFill>
+                <a:effectLst/>
+                <a:uFillTx/>
+                <a:latin typeface="Aptos"/>
+                <a:ea typeface="Aptos"/>
+              </a:rPr>
+              <a:t>Benign app mix (HTTP, MQTT, video, iperf3) and the Mirai SYN flood run together on the same uplink.</a:t>
+            </a:r>
+            <a:endParaRPr b="0" lang="en-US" sz="1600" strike="noStrike" u="none">
+              <a:solidFill>
+                <a:srgbClr val="000000"/>
+              </a:solidFill>
+              <a:effectLst/>
+              <a:uFillTx/>
+              <a:latin typeface="Arial"/>
+            </a:endParaRPr>
+          </a:p>
+          <a:p>
+            <a:pPr defTabSz="914400">
+              <a:lnSpc>
+                <a:spcPct val="100000"/>
+              </a:lnSpc>
+              <a:tabLst>
+                <a:tab algn="l" pos="0"/>
+              </a:tabLst>
+            </a:pPr>
+            <a:endParaRPr b="0" lang="en-US" sz="1600" strike="noStrike" u="none">
+              <a:solidFill>
+                <a:srgbClr val="000000"/>
+              </a:solidFill>
+              <a:effectLst/>
+              <a:uFillTx/>
+              <a:latin typeface="Arial"/>
+            </a:endParaRPr>
+          </a:p>
+          <a:p>
+            <a:pPr defTabSz="914400">
+              <a:lnSpc>
+                <a:spcPct val="100000"/>
+              </a:lnSpc>
+              <a:tabLst>
+                <a:tab algn="l" pos="0"/>
+              </a:tabLst>
+            </a:pPr>
+            <a:r>
+              <a:rPr b="0" lang="en-US" sz="1600" strike="noStrike" u="none">
+                <a:solidFill>
+                  <a:srgbClr val="11233b"/>
+                </a:solidFill>
+                <a:effectLst/>
+                <a:uFillTx/>
+                <a:latin typeface="Aptos"/>
+                <a:ea typeface="Aptos"/>
+              </a:rPr>
+              <a:t>The attack share fluctuates per chunk but averages ~30% across the 15 GB capture.</a:t>
+            </a:r>
+            <a:endParaRPr b="0" lang="en-US" sz="1600" strike="noStrike" u="none">
+              <a:solidFill>
+                <a:srgbClr val="000000"/>
+              </a:solidFill>
+              <a:effectLst/>
+              <a:uFillTx/>
+              <a:latin typeface="Arial"/>
+            </a:endParaRPr>
+          </a:p>
+          <a:p>
+            <a:pPr defTabSz="914400">
+              <a:lnSpc>
+                <a:spcPct val="100000"/>
+              </a:lnSpc>
+              <a:tabLst>
+                <a:tab algn="l" pos="0"/>
+              </a:tabLst>
+            </a:pPr>
+            <a:endParaRPr b="0" lang="en-US" sz="1600" strike="noStrike" u="none">
+              <a:solidFill>
+                <a:srgbClr val="000000"/>
+              </a:solidFill>
+              <a:effectLst/>
+              <a:uFillTx/>
+              <a:latin typeface="Arial"/>
+            </a:endParaRPr>
+          </a:p>
+          <a:p>
+            <a:pPr defTabSz="914400">
+              <a:lnSpc>
+                <a:spcPct val="100000"/>
+              </a:lnSpc>
+              <a:tabLst>
+                <a:tab algn="l" pos="0"/>
+              </a:tabLst>
+            </a:pPr>
+            <a:r>
+              <a:rPr b="0" lang="en-US" sz="1600" strike="noStrike" u="none">
+                <a:solidFill>
+                  <a:srgbClr val="11233b"/>
+                </a:solidFill>
+                <a:effectLst/>
+                <a:uFillTx/>
+                <a:latin typeface="Aptos"/>
+                <a:ea typeface="Aptos"/>
+              </a:rPr>
+              <a:t>The UERANSIM nr-ue uplink is patched (bounded queue) so the flood no longer wedges the UE tunnel.</a:t>
+            </a:r>
+            <a:endParaRPr b="0" lang="en-US" sz="1600" strike="noStrike" u="none">
+              <a:solidFill>
+                <a:srgbClr val="000000"/>
+              </a:solidFill>
+              <a:effectLst/>
+              <a:uFillTx/>
+              <a:latin typeface="Arial"/>
+            </a:endParaRPr>
+          </a:p>
+        </p:txBody>
+      </p:sp>
+    </p:spTree>
+  </p:cSld>
+  <mc:AlternateContent>
+    <mc:Choice Requires="p14">
+      <p:transition spd="slow" p14:dur="2000"/>
+    </mc:Choice>
+    <mc:Fallback>
+      <p:transition spd="slow"/>
+    </mc:Fallback>
+  </mc:AlternateContent>
+</p:sld>
+</file>
+
+<file path=ppt/slides/slide12.xml><?xml version="1.0" encoding="utf-8"?>
+<p:sld xmlns:a="http://schemas.openxmlformats.org/drawingml/2006/main" xmlns:p="http://schemas.openxmlformats.org/presentationml/2006/main" xmlns:r="http://schemas.openxmlformats.org/officeDocument/2006/relationships" xmlns:p14="http://schemas.microsoft.com/office/powerpoint/2010/main" xmlns:p15="http://schemas.microsoft.com/office/powerpoint/2012/main" xmlns:mc="http://schemas.openxmlformats.org/markup-compatibility/2006">
+  <p:cSld>
+    <p:bg>
+      <p:bgPr>
+        <a:solidFill>
+          <a:srgbClr val="ffffff"/>
+        </a:solidFill>
+      </p:bgPr>
+    </p:bg>
+    <p:spTree>
+      <p:nvGrpSpPr>
+        <p:cNvPr id="1" name=""/>
+        <p:cNvGrpSpPr/>
+        <p:nvPr/>
+      </p:nvGrpSpPr>
+      <p:grpSpPr>
+        <a:xfrm>
+          <a:off x="0" y="0"/>
+          <a:ext cx="0" cy="0"/>
+          <a:chOff x="0" y="0"/>
+          <a:chExt cx="0" cy="0"/>
+        </a:xfrm>
+      </p:grpSpPr>
+      <p:sp>
+        <p:nvSpPr>
+          <p:cNvPr id="163" name="Shape 0"/>
+          <p:cNvSpPr/>
+          <p:nvPr/>
+        </p:nvSpPr>
+        <p:spPr>
+          <a:xfrm>
+            <a:off x="0" y="0"/>
+            <a:ext cx="12191400" cy="109440"/>
+          </a:xfrm>
+          <a:prstGeom prst="rect">
+            <a:avLst/>
+          </a:prstGeom>
+          <a:solidFill>
+            <a:srgbClr val="ee791f"/>
+          </a:solidFill>
+          <a:ln w="12700">
+            <a:solidFill>
+              <a:srgbClr val="ee791f"/>
+            </a:solidFill>
+            <a:round/>
+          </a:ln>
+        </p:spPr>
+        <p:style>
+          <a:lnRef idx="0"/>
+          <a:fillRef idx="0"/>
+          <a:effectRef idx="0"/>
+          <a:fontRef idx="minor"/>
+        </p:style>
+        <p:txBody>
+          <a:bodyPr lIns="90000" rIns="90000" tIns="45000" bIns="45000" anchor="t">
+            <a:noAutofit/>
+          </a:bodyPr>
+          <a:p>
+            <a:endParaRPr b="0" lang="en-US" sz="1800" strike="noStrike" u="none">
+              <a:solidFill>
+                <a:srgbClr val="ffffff"/>
+              </a:solidFill>
+              <a:effectLst/>
+              <a:uFillTx/>
+              <a:latin typeface="Arial"/>
+            </a:endParaRPr>
+          </a:p>
+        </p:txBody>
+      </p:sp>
+      <p:sp>
+        <p:nvSpPr>
+          <p:cNvPr id="164" name="Text 1"/>
+          <p:cNvSpPr/>
+          <p:nvPr/>
+        </p:nvSpPr>
+        <p:spPr>
+          <a:xfrm>
+            <a:off x="530280" y="311040"/>
+            <a:ext cx="10881000" cy="548280"/>
+          </a:xfrm>
+          <a:prstGeom prst="rect">
+            <a:avLst/>
+          </a:prstGeom>
+          <a:noFill/>
+          <a:ln w="0">
+            <a:noFill/>
+          </a:ln>
+        </p:spPr>
+        <p:style>
+          <a:lnRef idx="0"/>
+          <a:fillRef idx="0"/>
+          <a:effectRef idx="0"/>
+          <a:fontRef idx="minor"/>
+        </p:style>
+        <p:txBody>
+          <a:bodyPr lIns="360" rIns="360" tIns="360" bIns="360" anchor="ctr">
+            <a:normAutofit/>
+          </a:bodyPr>
+          <a:p>
+            <a:pPr defTabSz="914400">
+              <a:lnSpc>
+                <a:spcPct val="100000"/>
+              </a:lnSpc>
+              <a:tabLst>
+                <a:tab algn="l" pos="0"/>
+              </a:tabLst>
+            </a:pPr>
+            <a:r>
+              <a:rPr b="1" lang="en-US" sz="2700" strike="noStrike" u="none">
+                <a:solidFill>
+                  <a:srgbClr val="11233b"/>
+                </a:solidFill>
+                <a:effectLst/>
+                <a:uFillTx/>
+                <a:latin typeface="Aptos"/>
+                <a:ea typeface="Aptos"/>
+              </a:rPr>
+              <a:t>Train and evaluate the per-packet detector</a:t>
+            </a:r>
+            <a:endParaRPr b="0" lang="en-US" sz="2700" strike="noStrike" u="none">
+              <a:solidFill>
+                <a:srgbClr val="000000"/>
+              </a:solidFill>
+              <a:effectLst/>
+              <a:uFillTx/>
+              <a:latin typeface="Arial"/>
+            </a:endParaRPr>
+          </a:p>
+        </p:txBody>
+      </p:sp>
+      <p:sp>
+        <p:nvSpPr>
+          <p:cNvPr id="165" name="Shape 2"/>
+          <p:cNvSpPr/>
+          <p:nvPr/>
+        </p:nvSpPr>
+        <p:spPr>
+          <a:xfrm>
+            <a:off x="530280" y="951120"/>
+            <a:ext cx="11100600" cy="31680"/>
+          </a:xfrm>
+          <a:prstGeom prst="rect">
+            <a:avLst/>
+          </a:prstGeom>
+          <a:solidFill>
+            <a:srgbClr val="ee791f"/>
+          </a:solidFill>
+          <a:ln w="12700">
+            <a:solidFill>
+              <a:srgbClr val="ee791f"/>
+            </a:solidFill>
+            <a:round/>
+          </a:ln>
+        </p:spPr>
+        <p:style>
+          <a:lnRef idx="0"/>
+          <a:fillRef idx="0"/>
+          <a:effectRef idx="0"/>
+          <a:fontRef idx="minor"/>
+        </p:style>
+        <p:txBody>
+          <a:bodyPr lIns="90000" rIns="90000" tIns="-12960" bIns="-12960" anchor="t">
+            <a:noAutofit/>
+          </a:bodyPr>
+          <a:p>
+            <a:endParaRPr b="0" lang="en-US" sz="1800" strike="noStrike" u="none">
+              <a:solidFill>
+                <a:srgbClr val="ffffff"/>
+              </a:solidFill>
+              <a:effectLst/>
+              <a:uFillTx/>
+              <a:latin typeface="Arial"/>
+            </a:endParaRPr>
+          </a:p>
+        </p:txBody>
+      </p:sp>
+      <p:sp>
+        <p:nvSpPr>
+          <p:cNvPr id="166" name="Text 3"/>
+          <p:cNvSpPr/>
+          <p:nvPr/>
+        </p:nvSpPr>
+        <p:spPr>
+          <a:xfrm>
+            <a:off x="548640" y="6473880"/>
+            <a:ext cx="9143640" cy="200880"/>
+          </a:xfrm>
+          <a:prstGeom prst="rect">
+            <a:avLst/>
+          </a:prstGeom>
+          <a:noFill/>
+          <a:ln w="0">
+            <a:noFill/>
+          </a:ln>
+        </p:spPr>
+        <p:style>
+          <a:lnRef idx="0"/>
+          <a:fillRef idx="0"/>
+          <a:effectRef idx="0"/>
+          <a:fontRef idx="minor"/>
+        </p:style>
+        <p:txBody>
+          <a:bodyPr lIns="360" rIns="360" tIns="360" bIns="360" anchor="ctr">
+            <a:normAutofit/>
+          </a:bodyPr>
+          <a:p>
+            <a:pPr defTabSz="914400">
+              <a:lnSpc>
+                <a:spcPct val="100000"/>
+              </a:lnSpc>
+              <a:tabLst>
+                <a:tab algn="l" pos="0"/>
+              </a:tabLst>
+            </a:pPr>
+            <a:r>
+              <a:rPr b="0" lang="en-US" sz="900" strike="noStrike" u="none">
+                <a:solidFill>
+                  <a:srgbClr val="586a79"/>
+                </a:solidFill>
+                <a:effectLst/>
+                <a:uFillTx/>
+                <a:latin typeface="Aptos"/>
+                <a:ea typeface="Aptos"/>
+              </a:rPr>
+              <a:t>6G-DALI  ×  NATWORK  |  LOCAL CYBERSECURITY HACKATHON</a:t>
+            </a:r>
+            <a:endParaRPr b="0" lang="en-US" sz="900" strike="noStrike" u="none">
+              <a:solidFill>
+                <a:srgbClr val="000000"/>
+              </a:solidFill>
+              <a:effectLst/>
+              <a:uFillTx/>
+              <a:latin typeface="Arial"/>
+            </a:endParaRPr>
+          </a:p>
+        </p:txBody>
+      </p:sp>
+      <p:sp>
+        <p:nvSpPr>
+          <p:cNvPr id="167" name="Text 4"/>
+          <p:cNvSpPr/>
+          <p:nvPr/>
+        </p:nvSpPr>
+        <p:spPr>
+          <a:xfrm>
+            <a:off x="11018520" y="6473880"/>
+            <a:ext cx="511560" cy="200880"/>
+          </a:xfrm>
+          <a:prstGeom prst="rect">
+            <a:avLst/>
+          </a:prstGeom>
+          <a:noFill/>
+          <a:ln w="0">
+            <a:noFill/>
+          </a:ln>
+        </p:spPr>
+        <p:style>
+          <a:lnRef idx="0"/>
+          <a:fillRef idx="0"/>
+          <a:effectRef idx="0"/>
+          <a:fontRef idx="minor"/>
+        </p:style>
+        <p:txBody>
+          <a:bodyPr lIns="360" rIns="360" tIns="360" bIns="360" anchor="ctr">
+            <a:normAutofit/>
+          </a:bodyPr>
+          <a:p>
+            <a:pPr algn="r" defTabSz="914400">
+              <a:lnSpc>
+                <a:spcPct val="100000"/>
+              </a:lnSpc>
+              <a:tabLst>
+                <a:tab algn="l" pos="0"/>
+              </a:tabLst>
+            </a:pPr>
+            <a:r>
+              <a:rPr b="0" lang="en-US" sz="900" strike="noStrike" u="none">
+                <a:solidFill>
+                  <a:srgbClr val="586a79"/>
+                </a:solidFill>
+                <a:effectLst/>
+                <a:uFillTx/>
+                <a:latin typeface="Aptos"/>
+                <a:ea typeface="Aptos"/>
+              </a:rPr>
+              <a:t>12</a:t>
+            </a:r>
+            <a:endParaRPr b="0" lang="en-US" sz="900" strike="noStrike" u="none">
+              <a:solidFill>
+                <a:srgbClr val="000000"/>
+              </a:solidFill>
+              <a:effectLst/>
+              <a:uFillTx/>
+              <a:latin typeface="Arial"/>
+            </a:endParaRPr>
+          </a:p>
+        </p:txBody>
+      </p:sp>
+      <p:sp>
+        <p:nvSpPr>
+          <p:cNvPr id="168" name="Shape 5"/>
+          <p:cNvSpPr/>
+          <p:nvPr/>
+        </p:nvSpPr>
+        <p:spPr>
+          <a:xfrm>
+            <a:off x="603360" y="1188720"/>
+            <a:ext cx="10999800" cy="1508400"/>
+          </a:xfrm>
+          <a:prstGeom prst="roundRect">
+            <a:avLst>
+              <a:gd name="adj" fmla="val 6061"/>
+            </a:avLst>
+          </a:prstGeom>
+          <a:solidFill>
+            <a:srgbClr val="11233b"/>
+          </a:solidFill>
+          <a:ln w="12700">
+            <a:solidFill>
+              <a:srgbClr val="11233b"/>
+            </a:solidFill>
+            <a:round/>
+          </a:ln>
+        </p:spPr>
+        <p:style>
+          <a:lnRef idx="0"/>
+          <a:fillRef idx="0"/>
+          <a:effectRef idx="0"/>
+          <a:fontRef idx="minor"/>
+        </p:style>
+        <p:txBody>
+          <a:bodyPr lIns="90000" rIns="90000" tIns="45000" bIns="45000" anchor="t">
+            <a:noAutofit/>
+          </a:bodyPr>
+          <a:p>
+            <a:endParaRPr b="0" lang="en-US" sz="1800" strike="noStrike" u="none">
+              <a:solidFill>
+                <a:srgbClr val="ffffff"/>
+              </a:solidFill>
+              <a:effectLst/>
+              <a:uFillTx/>
+              <a:latin typeface="Arial"/>
+            </a:endParaRPr>
+          </a:p>
+        </p:txBody>
+      </p:sp>
+      <p:sp>
+        <p:nvSpPr>
+          <p:cNvPr id="169" name="Text 6"/>
+          <p:cNvSpPr/>
+          <p:nvPr/>
+        </p:nvSpPr>
+        <p:spPr>
+          <a:xfrm>
+            <a:off x="786240" y="1298520"/>
+            <a:ext cx="10652400" cy="1325520"/>
+          </a:xfrm>
+          <a:prstGeom prst="rect">
+            <a:avLst/>
+          </a:prstGeom>
+          <a:noFill/>
+          <a:ln w="0">
+            <a:noFill/>
+          </a:ln>
+        </p:spPr>
+        <p:style>
+          <a:lnRef idx="0"/>
+          <a:fillRef idx="0"/>
+          <a:effectRef idx="0"/>
+          <a:fontRef idx="minor"/>
+        </p:style>
+        <p:txBody>
+          <a:bodyPr lIns="360" rIns="360" tIns="360" bIns="360" anchor="t">
+            <a:normAutofit/>
+          </a:bodyPr>
+          <a:p>
+            <a:pPr defTabSz="914400">
+              <a:lnSpc>
+                <a:spcPct val="100000"/>
+              </a:lnSpc>
+              <a:tabLst>
+                <a:tab algn="l" pos="0"/>
+              </a:tabLst>
+            </a:pPr>
+            <a:r>
+              <a:rPr b="0" lang="en-US" sz="1300" strike="noStrike" u="none">
+                <a:solidFill>
+                  <a:srgbClr val="e9f5fc"/>
+                </a:solidFill>
+                <a:effectLst/>
+                <a:uFillTx/>
+                <a:latin typeface="Aptos Mono"/>
+                <a:ea typeface="Aptos Mono"/>
+              </a:rPr>
+              <a:t>cd ddos_cnn_xgb</a:t>
+            </a:r>
+            <a:endParaRPr b="0" lang="en-US" sz="1300" strike="noStrike" u="none">
+              <a:solidFill>
+                <a:srgbClr val="000000"/>
+              </a:solidFill>
+              <a:effectLst/>
+              <a:uFillTx/>
+              <a:latin typeface="Arial"/>
+            </a:endParaRPr>
+          </a:p>
+          <a:p>
+            <a:pPr defTabSz="914400">
+              <a:lnSpc>
+                <a:spcPct val="100000"/>
+              </a:lnSpc>
+              <a:tabLst>
+                <a:tab algn="l" pos="0"/>
+              </a:tabLst>
+            </a:pPr>
+            <a:r>
+              <a:rPr b="0" lang="en-US" sz="1300" strike="noStrike" u="none">
+                <a:solidFill>
+                  <a:srgbClr val="e9f5fc"/>
+                </a:solidFill>
+                <a:effectLst/>
+                <a:uFillTx/>
+                <a:latin typeface="Aptos Mono"/>
+                <a:ea typeface="Aptos Mono"/>
+              </a:rPr>
+              <a:t>python3 -m venv .venv</a:t>
+            </a:r>
+            <a:endParaRPr b="0" lang="en-US" sz="1300" strike="noStrike" u="none">
+              <a:solidFill>
+                <a:srgbClr val="000000"/>
+              </a:solidFill>
+              <a:effectLst/>
+              <a:uFillTx/>
+              <a:latin typeface="Arial"/>
+            </a:endParaRPr>
+          </a:p>
+          <a:p>
+            <a:pPr defTabSz="914400">
+              <a:lnSpc>
+                <a:spcPct val="100000"/>
+              </a:lnSpc>
+              <a:tabLst>
+                <a:tab algn="l" pos="0"/>
+              </a:tabLst>
+            </a:pPr>
+            <a:r>
+              <a:rPr b="0" lang="en-US" sz="1300" strike="noStrike" u="none">
+                <a:solidFill>
+                  <a:srgbClr val="e9f5fc"/>
+                </a:solidFill>
+                <a:effectLst/>
+                <a:uFillTx/>
+                <a:latin typeface="Aptos Mono"/>
+                <a:ea typeface="Aptos Mono"/>
+              </a:rPr>
+              <a:t>.venv/bin/python -m pip install tensorflow h5py numpy scikit-learn</a:t>
+            </a:r>
+            <a:endParaRPr b="0" lang="en-US" sz="1300" strike="noStrike" u="none">
+              <a:solidFill>
+                <a:srgbClr val="000000"/>
+              </a:solidFill>
+              <a:effectLst/>
+              <a:uFillTx/>
+              <a:latin typeface="Arial"/>
+            </a:endParaRPr>
+          </a:p>
+          <a:p>
+            <a:pPr defTabSz="914400">
+              <a:lnSpc>
+                <a:spcPct val="100000"/>
+              </a:lnSpc>
+              <a:tabLst>
+                <a:tab algn="l" pos="0"/>
+              </a:tabLst>
+            </a:pPr>
+            <a:r>
+              <a:rPr b="0" lang="en-US" sz="1300" strike="noStrike" u="none">
+                <a:solidFill>
+                  <a:srgbClr val="e9f5fc"/>
+                </a:solidFill>
+                <a:effectLst/>
+                <a:uFillTx/>
+                <a:latin typeface="Aptos Mono"/>
+                <a:ea typeface="Aptos Mono"/>
+              </a:rPr>
+              <a:t># one command does compose + train + compare:</a:t>
+            </a:r>
+            <a:endParaRPr b="0" lang="en-US" sz="1300" strike="noStrike" u="none">
+              <a:solidFill>
+                <a:srgbClr val="000000"/>
+              </a:solidFill>
+              <a:effectLst/>
+              <a:uFillTx/>
+              <a:latin typeface="Arial"/>
+            </a:endParaRPr>
+          </a:p>
+          <a:p>
+            <a:pPr defTabSz="914400">
+              <a:lnSpc>
+                <a:spcPct val="100000"/>
+              </a:lnSpc>
+              <a:tabLst>
+                <a:tab algn="l" pos="0"/>
+              </a:tabLst>
+            </a:pPr>
+            <a:r>
+              <a:rPr b="0" lang="en-US" sz="1300" strike="noStrike" u="none">
+                <a:solidFill>
+                  <a:srgbClr val="e9f5fc"/>
+                </a:solidFill>
+                <a:effectLst/>
+                <a:uFillTx/>
+                <a:latin typeface="Aptos Mono"/>
+                <a:ea typeface="Aptos Mono"/>
+              </a:rPr>
+              <a:t>./run_final_pipeline.sh ../datasets/pcap_big bigrun</a:t>
+            </a:r>
+            <a:endParaRPr b="0" lang="en-US" sz="1300" strike="noStrike" u="none">
+              <a:solidFill>
+                <a:srgbClr val="000000"/>
+              </a:solidFill>
+              <a:effectLst/>
+              <a:uFillTx/>
+              <a:latin typeface="Arial"/>
+            </a:endParaRPr>
+          </a:p>
+        </p:txBody>
+      </p:sp>
+      <p:sp>
+        <p:nvSpPr>
+          <p:cNvPr id="170" name="Shape 7"/>
+          <p:cNvSpPr/>
+          <p:nvPr/>
+        </p:nvSpPr>
+        <p:spPr>
+          <a:xfrm>
+            <a:off x="631080" y="2907720"/>
+            <a:ext cx="10917720" cy="914040"/>
+          </a:xfrm>
+          <a:prstGeom prst="roundRect">
+            <a:avLst>
+              <a:gd name="adj" fmla="val 10000"/>
+            </a:avLst>
+          </a:prstGeom>
+          <a:solidFill>
+            <a:srgbClr val="edf5f8"/>
+          </a:solidFill>
+          <a:ln w="12700">
+            <a:solidFill>
+              <a:srgbClr val="edf5f8"/>
+            </a:solidFill>
+            <a:round/>
+          </a:ln>
+        </p:spPr>
+        <p:style>
+          <a:lnRef idx="0"/>
+          <a:fillRef idx="0"/>
+          <a:effectRef idx="0"/>
+          <a:fontRef idx="minor"/>
+        </p:style>
+        <p:txBody>
+          <a:bodyPr lIns="90000" rIns="90000" tIns="45000" bIns="45000" anchor="t">
+            <a:noAutofit/>
+          </a:bodyPr>
+          <a:p>
+            <a:endParaRPr b="0" lang="en-US" sz="1800" strike="noStrike" u="none">
+              <a:solidFill>
+                <a:srgbClr val="000000"/>
+              </a:solidFill>
+              <a:effectLst/>
+              <a:uFillTx/>
+              <a:latin typeface="Arial"/>
+            </a:endParaRPr>
+          </a:p>
+        </p:txBody>
+      </p:sp>
+      <p:sp>
+        <p:nvSpPr>
+          <p:cNvPr id="171" name="Text 8"/>
+          <p:cNvSpPr/>
+          <p:nvPr/>
+        </p:nvSpPr>
+        <p:spPr>
+          <a:xfrm>
+            <a:off x="804600" y="3017520"/>
+            <a:ext cx="2011320" cy="273960"/>
+          </a:xfrm>
+          <a:prstGeom prst="rect">
+            <a:avLst/>
+          </a:prstGeom>
+          <a:noFill/>
+          <a:ln w="0">
+            <a:noFill/>
+          </a:ln>
+        </p:spPr>
+        <p:style>
+          <a:lnRef idx="0"/>
+          <a:fillRef idx="0"/>
+          <a:effectRef idx="0"/>
+          <a:fontRef idx="minor"/>
+        </p:style>
+        <p:txBody>
+          <a:bodyPr lIns="360" rIns="360" tIns="360" bIns="360" anchor="ctr">
+            <a:normAutofit/>
+          </a:bodyPr>
+          <a:p>
+            <a:pPr defTabSz="914400">
+              <a:lnSpc>
+                <a:spcPct val="100000"/>
+              </a:lnSpc>
+              <a:tabLst>
+                <a:tab algn="l" pos="0"/>
+              </a:tabLst>
+            </a:pPr>
+            <a:r>
+              <a:rPr b="1" lang="en-US" sz="1500" strike="noStrike" u="none">
+                <a:solidFill>
+                  <a:srgbClr val="ee791f"/>
+                </a:solidFill>
+                <a:effectLst/>
+                <a:uFillTx/>
+                <a:latin typeface="Aptos"/>
+                <a:ea typeface="Aptos"/>
+              </a:rPr>
+              <a:t>01  COMPOSE</a:t>
+            </a:r>
+            <a:endParaRPr b="0" lang="en-US" sz="1500" strike="noStrike" u="none">
+              <a:solidFill>
+                <a:srgbClr val="000000"/>
+              </a:solidFill>
+              <a:effectLst/>
+              <a:uFillTx/>
+              <a:latin typeface="Arial"/>
+            </a:endParaRPr>
+          </a:p>
+        </p:txBody>
+      </p:sp>
+      <p:sp>
+        <p:nvSpPr>
+          <p:cNvPr id="172" name="Text 9"/>
+          <p:cNvSpPr/>
+          <p:nvPr/>
+        </p:nvSpPr>
+        <p:spPr>
+          <a:xfrm>
+            <a:off x="2752200" y="2990160"/>
+            <a:ext cx="8412120" cy="282960"/>
+          </a:xfrm>
+          <a:prstGeom prst="rect">
+            <a:avLst/>
+          </a:prstGeom>
+          <a:noFill/>
+          <a:ln w="0">
+            <a:noFill/>
+          </a:ln>
+        </p:spPr>
+        <p:style>
+          <a:lnRef idx="0"/>
+          <a:fillRef idx="0"/>
+          <a:effectRef idx="0"/>
+          <a:fontRef idx="minor"/>
+        </p:style>
+        <p:txBody>
+          <a:bodyPr lIns="360" rIns="360" tIns="360" bIns="360" anchor="ctr">
+            <a:normAutofit/>
+          </a:bodyPr>
+          <a:p>
+            <a:pPr defTabSz="914400">
+              <a:lnSpc>
+                <a:spcPct val="100000"/>
+              </a:lnSpc>
+              <a:tabLst>
+                <a:tab algn="l" pos="0"/>
+              </a:tabLst>
+            </a:pPr>
+            <a:r>
+              <a:rPr b="1" lang="en-US" sz="1500" strike="noStrike" u="none">
+                <a:solidFill>
+                  <a:srgbClr val="11233b"/>
+                </a:solidFill>
+                <a:effectLst/>
+                <a:uFillTx/>
+                <a:latin typeface="Aptos Mono"/>
+                <a:ea typeface="Aptos Mono"/>
+              </a:rPr>
+              <a:t>.venv/bin/python build_mixed_windows.py</a:t>
+            </a:r>
+            <a:endParaRPr b="0" lang="en-US" sz="1500" strike="noStrike" u="none">
+              <a:solidFill>
+                <a:srgbClr val="000000"/>
+              </a:solidFill>
+              <a:effectLst/>
+              <a:uFillTx/>
+              <a:latin typeface="Arial"/>
+            </a:endParaRPr>
+          </a:p>
+        </p:txBody>
+      </p:sp>
+      <p:sp>
+        <p:nvSpPr>
+          <p:cNvPr id="173" name="Text 10"/>
+          <p:cNvSpPr/>
+          <p:nvPr/>
+        </p:nvSpPr>
+        <p:spPr>
+          <a:xfrm>
+            <a:off x="2761560" y="3319200"/>
+            <a:ext cx="8476200" cy="383760"/>
+          </a:xfrm>
+          <a:prstGeom prst="rect">
+            <a:avLst/>
+          </a:prstGeom>
+          <a:noFill/>
+          <a:ln w="0">
+            <a:noFill/>
+          </a:ln>
+        </p:spPr>
+        <p:style>
+          <a:lnRef idx="0"/>
+          <a:fillRef idx="0"/>
+          <a:effectRef idx="0"/>
+          <a:fontRef idx="minor"/>
+        </p:style>
+        <p:txBody>
+          <a:bodyPr lIns="360" rIns="360" tIns="360" bIns="360" anchor="ctr">
+            <a:normAutofit/>
+          </a:bodyPr>
+          <a:p>
+            <a:pPr defTabSz="914400">
+              <a:lnSpc>
+                <a:spcPct val="100000"/>
+              </a:lnSpc>
+              <a:tabLst>
+                <a:tab algn="l" pos="0"/>
+              </a:tabLst>
+            </a:pPr>
+            <a:r>
+              <a:rPr b="0" lang="en-US" sz="1100" strike="noStrike" u="none">
+                <a:solidFill>
+                  <a:srgbClr val="586a79"/>
+                </a:solidFill>
+                <a:effectLst/>
+                <a:uFillTx/>
+                <a:latin typeface="Aptos Mono"/>
+                <a:ea typeface="Aptos Mono"/>
+              </a:rPr>
+              <a:t>-i ../datasets/pcap_big -o bigrun/mixed_masked.h5</a:t>
+            </a:r>
+            <a:endParaRPr b="0" lang="en-US" sz="1100" strike="noStrike" u="none">
+              <a:solidFill>
+                <a:srgbClr val="000000"/>
+              </a:solidFill>
+              <a:effectLst/>
+              <a:uFillTx/>
+              <a:latin typeface="Arial"/>
+            </a:endParaRPr>
+          </a:p>
+          <a:p>
+            <a:pPr defTabSz="914400">
+              <a:lnSpc>
+                <a:spcPct val="100000"/>
+              </a:lnSpc>
+              <a:tabLst>
+                <a:tab algn="l" pos="0"/>
+              </a:tabLst>
+            </a:pPr>
+            <a:r>
+              <a:rPr b="0" lang="en-US" sz="1100" strike="noStrike" u="none">
+                <a:solidFill>
+                  <a:srgbClr val="586a79"/>
+                </a:solidFill>
+                <a:effectLst/>
+                <a:uFillTx/>
+                <a:latin typeface="Aptos Mono"/>
+                <a:ea typeface="Aptos Mono"/>
+              </a:rPr>
+              <a:t>-w 100 -p 64 --attack-frac 0.30   (fluctuating, address-randomized)</a:t>
+            </a:r>
+            <a:endParaRPr b="0" lang="en-US" sz="1100" strike="noStrike" u="none">
+              <a:solidFill>
+                <a:srgbClr val="000000"/>
+              </a:solidFill>
+              <a:effectLst/>
+              <a:uFillTx/>
+              <a:latin typeface="Arial"/>
+            </a:endParaRPr>
+          </a:p>
+        </p:txBody>
+      </p:sp>
+      <p:sp>
+        <p:nvSpPr>
+          <p:cNvPr id="174" name="Shape 11"/>
+          <p:cNvSpPr/>
+          <p:nvPr/>
+        </p:nvSpPr>
+        <p:spPr>
+          <a:xfrm>
+            <a:off x="631080" y="3913560"/>
+            <a:ext cx="10917720" cy="914040"/>
+          </a:xfrm>
+          <a:prstGeom prst="roundRect">
+            <a:avLst>
+              <a:gd name="adj" fmla="val 10000"/>
+            </a:avLst>
+          </a:prstGeom>
+          <a:solidFill>
+            <a:srgbClr val="f2f6fa"/>
+          </a:solidFill>
+          <a:ln w="12700">
+            <a:solidFill>
+              <a:srgbClr val="f2f6fa"/>
+            </a:solidFill>
+            <a:round/>
+          </a:ln>
+        </p:spPr>
+        <p:style>
+          <a:lnRef idx="0"/>
+          <a:fillRef idx="0"/>
+          <a:effectRef idx="0"/>
+          <a:fontRef idx="minor"/>
+        </p:style>
+        <p:txBody>
+          <a:bodyPr lIns="90000" rIns="90000" tIns="45000" bIns="45000" anchor="t">
+            <a:noAutofit/>
+          </a:bodyPr>
+          <a:p>
+            <a:endParaRPr b="0" lang="en-US" sz="1800" strike="noStrike" u="none">
+              <a:solidFill>
+                <a:srgbClr val="000000"/>
+              </a:solidFill>
+              <a:effectLst/>
+              <a:uFillTx/>
+              <a:latin typeface="Arial"/>
+            </a:endParaRPr>
+          </a:p>
+        </p:txBody>
+      </p:sp>
+      <p:sp>
+        <p:nvSpPr>
+          <p:cNvPr id="175" name="Text 12"/>
+          <p:cNvSpPr/>
+          <p:nvPr/>
+        </p:nvSpPr>
+        <p:spPr>
+          <a:xfrm>
+            <a:off x="804600" y="4023360"/>
+            <a:ext cx="2011320" cy="273960"/>
+          </a:xfrm>
+          <a:prstGeom prst="rect">
+            <a:avLst/>
+          </a:prstGeom>
+          <a:noFill/>
+          <a:ln w="0">
+            <a:noFill/>
+          </a:ln>
+        </p:spPr>
+        <p:style>
+          <a:lnRef idx="0"/>
+          <a:fillRef idx="0"/>
+          <a:effectRef idx="0"/>
+          <a:fontRef idx="minor"/>
+        </p:style>
+        <p:txBody>
+          <a:bodyPr lIns="360" rIns="360" tIns="360" bIns="360" anchor="ctr">
+            <a:normAutofit/>
+          </a:bodyPr>
+          <a:p>
+            <a:pPr defTabSz="914400">
+              <a:lnSpc>
+                <a:spcPct val="100000"/>
+              </a:lnSpc>
+              <a:tabLst>
+                <a:tab algn="l" pos="0"/>
+              </a:tabLst>
+            </a:pPr>
+            <a:r>
+              <a:rPr b="1" lang="en-US" sz="1500" strike="noStrike" u="none">
+                <a:solidFill>
+                  <a:srgbClr val="ee791f"/>
+                </a:solidFill>
+                <a:effectLst/>
+                <a:uFillTx/>
+                <a:latin typeface="Aptos"/>
+                <a:ea typeface="Aptos"/>
+              </a:rPr>
+              <a:t>02  TRAIN</a:t>
+            </a:r>
+            <a:endParaRPr b="0" lang="en-US" sz="1500" strike="noStrike" u="none">
+              <a:solidFill>
+                <a:srgbClr val="000000"/>
+              </a:solidFill>
+              <a:effectLst/>
+              <a:uFillTx/>
+              <a:latin typeface="Arial"/>
+            </a:endParaRPr>
+          </a:p>
+        </p:txBody>
+      </p:sp>
+      <p:sp>
+        <p:nvSpPr>
+          <p:cNvPr id="176" name="Text 13"/>
+          <p:cNvSpPr/>
+          <p:nvPr/>
+        </p:nvSpPr>
+        <p:spPr>
+          <a:xfrm>
+            <a:off x="2752200" y="3996000"/>
+            <a:ext cx="8412120" cy="282960"/>
+          </a:xfrm>
+          <a:prstGeom prst="rect">
+            <a:avLst/>
+          </a:prstGeom>
+          <a:noFill/>
+          <a:ln w="0">
+            <a:noFill/>
+          </a:ln>
+        </p:spPr>
+        <p:style>
+          <a:lnRef idx="0"/>
+          <a:fillRef idx="0"/>
+          <a:effectRef idx="0"/>
+          <a:fontRef idx="minor"/>
+        </p:style>
+        <p:txBody>
+          <a:bodyPr lIns="360" rIns="360" tIns="360" bIns="360" anchor="ctr">
+            <a:normAutofit/>
+          </a:bodyPr>
+          <a:p>
+            <a:pPr defTabSz="914400">
+              <a:lnSpc>
+                <a:spcPct val="100000"/>
+              </a:lnSpc>
+              <a:tabLst>
+                <a:tab algn="l" pos="0"/>
+              </a:tabLst>
+            </a:pPr>
+            <a:r>
+              <a:rPr b="1" lang="en-US" sz="1500" strike="noStrike" u="none">
+                <a:solidFill>
+                  <a:srgbClr val="11233b"/>
+                </a:solidFill>
+                <a:effectLst/>
+                <a:uFillTx/>
+                <a:latin typeface="Aptos Mono"/>
+                <a:ea typeface="Aptos Mono"/>
+              </a:rPr>
+              <a:t>.venv/bin/python train_model.py --arch perpacket --loss bce</a:t>
+            </a:r>
+            <a:endParaRPr b="0" lang="en-US" sz="1500" strike="noStrike" u="none">
+              <a:solidFill>
+                <a:srgbClr val="000000"/>
+              </a:solidFill>
+              <a:effectLst/>
+              <a:uFillTx/>
+              <a:latin typeface="Arial"/>
+            </a:endParaRPr>
+          </a:p>
+        </p:txBody>
+      </p:sp>
+      <p:sp>
+        <p:nvSpPr>
+          <p:cNvPr id="177" name="Text 14"/>
+          <p:cNvSpPr/>
+          <p:nvPr/>
+        </p:nvSpPr>
+        <p:spPr>
+          <a:xfrm>
+            <a:off x="2761560" y="4325040"/>
+            <a:ext cx="8476200" cy="383760"/>
+          </a:xfrm>
+          <a:prstGeom prst="rect">
+            <a:avLst/>
+          </a:prstGeom>
+          <a:noFill/>
+          <a:ln w="0">
+            <a:noFill/>
+          </a:ln>
+        </p:spPr>
+        <p:style>
+          <a:lnRef idx="0"/>
+          <a:fillRef idx="0"/>
+          <a:effectRef idx="0"/>
+          <a:fontRef idx="minor"/>
+        </p:style>
+        <p:txBody>
+          <a:bodyPr lIns="360" rIns="360" tIns="360" bIns="360" anchor="ctr">
+            <a:normAutofit/>
+          </a:bodyPr>
+          <a:p>
+            <a:pPr defTabSz="914400">
+              <a:lnSpc>
+                <a:spcPct val="100000"/>
+              </a:lnSpc>
+              <a:tabLst>
+                <a:tab algn="l" pos="0"/>
+              </a:tabLst>
+            </a:pPr>
+            <a:r>
+              <a:rPr b="0" lang="en-US" sz="1100" strike="noStrike" u="none">
+                <a:solidFill>
+                  <a:srgbClr val="586a79"/>
+                </a:solidFill>
+                <a:effectLst/>
+                <a:uFillTx/>
+                <a:latin typeface="Aptos Mono"/>
+                <a:ea typeface="Aptos Mono"/>
+              </a:rPr>
+              <a:t>-i bigrun/mixed_masked.h5 -o bigrun/perpacket</a:t>
+            </a:r>
+            <a:endParaRPr b="0" lang="en-US" sz="1100" strike="noStrike" u="none">
+              <a:solidFill>
+                <a:srgbClr val="000000"/>
+              </a:solidFill>
+              <a:effectLst/>
+              <a:uFillTx/>
+              <a:latin typeface="Arial"/>
+            </a:endParaRPr>
+          </a:p>
+          <a:p>
+            <a:pPr defTabSz="914400">
+              <a:lnSpc>
+                <a:spcPct val="100000"/>
+              </a:lnSpc>
+              <a:tabLst>
+                <a:tab algn="l" pos="0"/>
+              </a:tabLst>
+            </a:pPr>
+            <a:r>
+              <a:rPr b="0" lang="en-US" sz="1100" strike="noStrike" u="none">
+                <a:solidFill>
+                  <a:srgbClr val="586a79"/>
+                </a:solidFill>
+                <a:effectLst/>
+                <a:uFillTx/>
+                <a:latin typeface="Aptos Mono"/>
+                <a:ea typeface="Aptos Mono"/>
+              </a:rPr>
+              <a:t>--train-cap 150000 --epochs 8   (per-packet head, ~38k params)</a:t>
+            </a:r>
+            <a:endParaRPr b="0" lang="en-US" sz="1100" strike="noStrike" u="none">
+              <a:solidFill>
+                <a:srgbClr val="000000"/>
+              </a:solidFill>
+              <a:effectLst/>
+              <a:uFillTx/>
+              <a:latin typeface="Arial"/>
+            </a:endParaRPr>
+          </a:p>
+        </p:txBody>
+      </p:sp>
+      <p:sp>
+        <p:nvSpPr>
+          <p:cNvPr id="178" name="Shape 15"/>
+          <p:cNvSpPr/>
+          <p:nvPr/>
+        </p:nvSpPr>
+        <p:spPr>
+          <a:xfrm>
+            <a:off x="631080" y="4919400"/>
+            <a:ext cx="10917720" cy="914040"/>
+          </a:xfrm>
+          <a:prstGeom prst="roundRect">
+            <a:avLst>
+              <a:gd name="adj" fmla="val 10000"/>
+            </a:avLst>
+          </a:prstGeom>
+          <a:solidFill>
+            <a:srgbClr val="edf5f8"/>
+          </a:solidFill>
+          <a:ln w="12700">
+            <a:solidFill>
+              <a:srgbClr val="edf5f8"/>
+            </a:solidFill>
+            <a:round/>
+          </a:ln>
+        </p:spPr>
+        <p:style>
+          <a:lnRef idx="0"/>
+          <a:fillRef idx="0"/>
+          <a:effectRef idx="0"/>
+          <a:fontRef idx="minor"/>
+        </p:style>
+        <p:txBody>
+          <a:bodyPr lIns="90000" rIns="90000" tIns="45000" bIns="45000" anchor="t">
+            <a:noAutofit/>
+          </a:bodyPr>
+          <a:p>
+            <a:endParaRPr b="0" lang="en-US" sz="1800" strike="noStrike" u="none">
+              <a:solidFill>
+                <a:srgbClr val="000000"/>
+              </a:solidFill>
+              <a:effectLst/>
+              <a:uFillTx/>
+              <a:latin typeface="Arial"/>
+            </a:endParaRPr>
+          </a:p>
+        </p:txBody>
+      </p:sp>
+      <p:sp>
+        <p:nvSpPr>
+          <p:cNvPr id="179" name="Text 16"/>
+          <p:cNvSpPr/>
+          <p:nvPr/>
+        </p:nvSpPr>
+        <p:spPr>
+          <a:xfrm>
+            <a:off x="804600" y="5029200"/>
+            <a:ext cx="2011320" cy="273960"/>
+          </a:xfrm>
+          <a:prstGeom prst="rect">
+            <a:avLst/>
+          </a:prstGeom>
+          <a:noFill/>
+          <a:ln w="0">
+            <a:noFill/>
+          </a:ln>
+        </p:spPr>
+        <p:style>
+          <a:lnRef idx="0"/>
+          <a:fillRef idx="0"/>
+          <a:effectRef idx="0"/>
+          <a:fontRef idx="minor"/>
+        </p:style>
+        <p:txBody>
+          <a:bodyPr lIns="360" rIns="360" tIns="360" bIns="360" anchor="ctr">
+            <a:normAutofit/>
+          </a:bodyPr>
+          <a:p>
+            <a:pPr defTabSz="914400">
+              <a:lnSpc>
+                <a:spcPct val="100000"/>
+              </a:lnSpc>
+              <a:tabLst>
+                <a:tab algn="l" pos="0"/>
+              </a:tabLst>
+            </a:pPr>
+            <a:r>
+              <a:rPr b="1" lang="en-US" sz="1500" strike="noStrike" u="none">
+                <a:solidFill>
+                  <a:srgbClr val="ee791f"/>
+                </a:solidFill>
+                <a:effectLst/>
+                <a:uFillTx/>
+                <a:latin typeface="Aptos"/>
+                <a:ea typeface="Aptos"/>
+              </a:rPr>
+              <a:t>03  COMPARE</a:t>
+            </a:r>
+            <a:endParaRPr b="0" lang="en-US" sz="1500" strike="noStrike" u="none">
+              <a:solidFill>
+                <a:srgbClr val="000000"/>
+              </a:solidFill>
+              <a:effectLst/>
+              <a:uFillTx/>
+              <a:latin typeface="Arial"/>
+            </a:endParaRPr>
+          </a:p>
+        </p:txBody>
+      </p:sp>
+      <p:sp>
+        <p:nvSpPr>
+          <p:cNvPr id="180" name="Text 17"/>
+          <p:cNvSpPr/>
+          <p:nvPr/>
+        </p:nvSpPr>
+        <p:spPr>
+          <a:xfrm>
+            <a:off x="2752200" y="5001840"/>
+            <a:ext cx="8412120" cy="282960"/>
+          </a:xfrm>
+          <a:prstGeom prst="rect">
+            <a:avLst/>
+          </a:prstGeom>
+          <a:noFill/>
+          <a:ln w="0">
+            <a:noFill/>
+          </a:ln>
+        </p:spPr>
+        <p:style>
+          <a:lnRef idx="0"/>
+          <a:fillRef idx="0"/>
+          <a:effectRef idx="0"/>
+          <a:fontRef idx="minor"/>
+        </p:style>
+        <p:txBody>
+          <a:bodyPr lIns="360" rIns="360" tIns="360" bIns="360" anchor="ctr">
+            <a:normAutofit/>
+          </a:bodyPr>
+          <a:p>
+            <a:pPr defTabSz="914400">
+              <a:lnSpc>
+                <a:spcPct val="100000"/>
+              </a:lnSpc>
+              <a:tabLst>
+                <a:tab algn="l" pos="0"/>
+              </a:tabLst>
+            </a:pPr>
+            <a:r>
+              <a:rPr b="1" lang="en-US" sz="1500" strike="noStrike" u="none">
+                <a:solidFill>
+                  <a:srgbClr val="11233b"/>
+                </a:solidFill>
+                <a:effectLst/>
+                <a:uFillTx/>
+                <a:latin typeface="Aptos Mono"/>
+                <a:ea typeface="Aptos Mono"/>
+              </a:rPr>
+              <a:t>.venv/bin/python evaluate_compare.py --csv bigrun/comparison.csv</a:t>
+            </a:r>
+            <a:endParaRPr b="0" lang="en-US" sz="1500" strike="noStrike" u="none">
+              <a:solidFill>
+                <a:srgbClr val="000000"/>
+              </a:solidFill>
+              <a:effectLst/>
+              <a:uFillTx/>
+              <a:latin typeface="Arial"/>
+            </a:endParaRPr>
+          </a:p>
+        </p:txBody>
+      </p:sp>
+      <p:sp>
+        <p:nvSpPr>
+          <p:cNvPr id="181" name="Text 18"/>
+          <p:cNvSpPr/>
+          <p:nvPr/>
+        </p:nvSpPr>
+        <p:spPr>
+          <a:xfrm>
+            <a:off x="2761560" y="5330880"/>
+            <a:ext cx="8476200" cy="383760"/>
+          </a:xfrm>
+          <a:prstGeom prst="rect">
+            <a:avLst/>
+          </a:prstGeom>
+          <a:noFill/>
+          <a:ln w="0">
+            <a:noFill/>
+          </a:ln>
+        </p:spPr>
+        <p:style>
+          <a:lnRef idx="0"/>
+          <a:fillRef idx="0"/>
+          <a:effectRef idx="0"/>
+          <a:fontRef idx="minor"/>
+        </p:style>
+        <p:txBody>
+          <a:bodyPr lIns="360" rIns="360" tIns="360" bIns="360" anchor="ctr">
+            <a:normAutofit/>
+          </a:bodyPr>
+          <a:p>
+            <a:pPr defTabSz="914400">
+              <a:lnSpc>
+                <a:spcPct val="100000"/>
+              </a:lnSpc>
+              <a:tabLst>
+                <a:tab algn="l" pos="0"/>
+              </a:tabLst>
+            </a:pPr>
+            <a:r>
+              <a:rPr b="0" lang="en-US" sz="1100" strike="noStrike" u="none">
+                <a:solidFill>
+                  <a:srgbClr val="586a79"/>
+                </a:solidFill>
+                <a:effectLst/>
+                <a:uFillTx/>
+                <a:latin typeface="Aptos Mono"/>
+                <a:ea typeface="Aptos Mono"/>
+              </a:rPr>
+              <a:t>-m shipped best_run/run_003 -m perpacket bigrun/perpacket</a:t>
+            </a:r>
+            <a:endParaRPr b="0" lang="en-US" sz="1100" strike="noStrike" u="none">
+              <a:solidFill>
+                <a:srgbClr val="000000"/>
+              </a:solidFill>
+              <a:effectLst/>
+              <a:uFillTx/>
+              <a:latin typeface="Arial"/>
+            </a:endParaRPr>
+          </a:p>
+          <a:p>
+            <a:pPr defTabSz="914400">
+              <a:lnSpc>
+                <a:spcPct val="100000"/>
+              </a:lnSpc>
+              <a:tabLst>
+                <a:tab algn="l" pos="0"/>
+              </a:tabLst>
+            </a:pPr>
+            <a:r>
+              <a:rPr b="0" lang="en-US" sz="1100" strike="noStrike" u="none">
+                <a:solidFill>
+                  <a:srgbClr val="586a79"/>
+                </a:solidFill>
+                <a:effectLst/>
+                <a:uFillTx/>
+                <a:latin typeface="Aptos Mono"/>
+                <a:ea typeface="Aptos Mono"/>
+              </a:rPr>
+              <a:t>--eval-cap 60000   (same held-out split for every model)</a:t>
+            </a:r>
+            <a:endParaRPr b="0" lang="en-US" sz="1100" strike="noStrike" u="none">
+              <a:solidFill>
+                <a:srgbClr val="000000"/>
+              </a:solidFill>
+              <a:effectLst/>
+              <a:uFillTx/>
+              <a:latin typeface="Arial"/>
+            </a:endParaRPr>
+          </a:p>
+        </p:txBody>
+      </p:sp>
+    </p:spTree>
+  </p:cSld>
+  <mc:AlternateContent>
+    <mc:Choice Requires="p14">
+      <p:transition spd="slow" p14:dur="2000"/>
+    </mc:Choice>
+    <mc:Fallback>
+      <p:transition spd="slow"/>
+    </mc:Fallback>
+  </mc:AlternateContent>
+</p:sld>
+</file>
+
+<file path=ppt/slides/slide13.xml><?xml version="1.0" encoding="utf-8"?>
+<p:sld xmlns:a="http://schemas.openxmlformats.org/drawingml/2006/main" xmlns:p="http://schemas.openxmlformats.org/presentationml/2006/main" xmlns:r="http://schemas.openxmlformats.org/officeDocument/2006/relationships" xmlns:p14="http://schemas.microsoft.com/office/powerpoint/2010/main" xmlns:p15="http://schemas.microsoft.com/office/powerpoint/2012/main" xmlns:mc="http://schemas.openxmlformats.org/markup-compatibility/2006">
+  <p:cSld>
+    <p:bg>
+      <p:bgPr>
+        <a:solidFill>
+          <a:srgbClr val="ffffff"/>
+        </a:solidFill>
+      </p:bgPr>
+    </p:bg>
+    <p:spTree>
+      <p:nvGrpSpPr>
+        <p:cNvPr id="1" name=""/>
+        <p:cNvGrpSpPr/>
+        <p:nvPr/>
+      </p:nvGrpSpPr>
+      <p:grpSpPr>
+        <a:xfrm>
+          <a:off x="0" y="0"/>
+          <a:ext cx="0" cy="0"/>
+          <a:chOff x="0" y="0"/>
+          <a:chExt cx="0" cy="0"/>
+        </a:xfrm>
+      </p:grpSpPr>
+      <p:sp>
+        <p:nvSpPr>
+          <p:cNvPr id="182" name="Shape 0"/>
+          <p:cNvSpPr/>
+          <p:nvPr/>
+        </p:nvSpPr>
+        <p:spPr>
+          <a:xfrm>
+            <a:off x="0" y="0"/>
+            <a:ext cx="12191400" cy="109440"/>
+          </a:xfrm>
+          <a:prstGeom prst="rect">
+            <a:avLst/>
+          </a:prstGeom>
+          <a:solidFill>
+            <a:srgbClr val="ee791f"/>
+          </a:solidFill>
+          <a:ln w="12700">
+            <a:solidFill>
+              <a:srgbClr val="ee791f"/>
+            </a:solidFill>
+            <a:round/>
+          </a:ln>
+        </p:spPr>
+        <p:style>
+          <a:lnRef idx="0"/>
+          <a:fillRef idx="0"/>
+          <a:effectRef idx="0"/>
+          <a:fontRef idx="minor"/>
+        </p:style>
+        <p:txBody>
+          <a:bodyPr lIns="90000" rIns="90000" tIns="45000" bIns="45000" anchor="t">
+            <a:noAutofit/>
+          </a:bodyPr>
+          <a:p>
+            <a:endParaRPr b="0" lang="en-US" sz="1800" strike="noStrike" u="none">
+              <a:solidFill>
+                <a:srgbClr val="ffffff"/>
+              </a:solidFill>
+              <a:effectLst/>
+              <a:uFillTx/>
+              <a:latin typeface="Arial"/>
+            </a:endParaRPr>
+          </a:p>
+        </p:txBody>
+      </p:sp>
+      <p:sp>
+        <p:nvSpPr>
+          <p:cNvPr id="183" name="Text 1"/>
+          <p:cNvSpPr/>
+          <p:nvPr/>
+        </p:nvSpPr>
+        <p:spPr>
+          <a:xfrm>
+            <a:off x="530280" y="311040"/>
+            <a:ext cx="10881000" cy="548280"/>
+          </a:xfrm>
+          <a:prstGeom prst="rect">
+            <a:avLst/>
+          </a:prstGeom>
+          <a:noFill/>
+          <a:ln w="0">
+            <a:noFill/>
+          </a:ln>
+        </p:spPr>
+        <p:style>
+          <a:lnRef idx="0"/>
+          <a:fillRef idx="0"/>
+          <a:effectRef idx="0"/>
+          <a:fontRef idx="minor"/>
+        </p:style>
+        <p:txBody>
+          <a:bodyPr lIns="360" rIns="360" tIns="360" bIns="360" anchor="ctr">
+            <a:normAutofit/>
+          </a:bodyPr>
+          <a:p>
+            <a:pPr defTabSz="914400">
+              <a:lnSpc>
+                <a:spcPct val="100000"/>
+              </a:lnSpc>
+              <a:tabLst>
+                <a:tab algn="l" pos="0"/>
+              </a:tabLst>
+            </a:pPr>
+            <a:r>
+              <a:rPr b="1" lang="en-US" sz="2700" strike="noStrike" u="none">
+                <a:solidFill>
+                  <a:srgbClr val="11233b"/>
+                </a:solidFill>
+                <a:effectLst/>
+                <a:uFillTx/>
+                <a:latin typeface="Aptos"/>
+                <a:ea typeface="Aptos"/>
+              </a:rPr>
+              <a:t>Result — per-packet CNN meets the NATWORK KPIs</a:t>
+            </a:r>
+            <a:endParaRPr b="0" lang="en-US" sz="2700" strike="noStrike" u="none">
+              <a:solidFill>
+                <a:srgbClr val="000000"/>
+              </a:solidFill>
+              <a:effectLst/>
+              <a:uFillTx/>
+              <a:latin typeface="Arial"/>
+            </a:endParaRPr>
+          </a:p>
+        </p:txBody>
+      </p:sp>
+      <p:sp>
+        <p:nvSpPr>
+          <p:cNvPr id="184" name="Shape 2"/>
+          <p:cNvSpPr/>
+          <p:nvPr/>
+        </p:nvSpPr>
+        <p:spPr>
+          <a:xfrm>
+            <a:off x="530280" y="951120"/>
+            <a:ext cx="11100600" cy="31680"/>
+          </a:xfrm>
+          <a:prstGeom prst="rect">
+            <a:avLst/>
+          </a:prstGeom>
+          <a:solidFill>
+            <a:srgbClr val="ee791f"/>
+          </a:solidFill>
+          <a:ln w="12700">
+            <a:solidFill>
+              <a:srgbClr val="ee791f"/>
+            </a:solidFill>
+            <a:round/>
+          </a:ln>
+        </p:spPr>
+        <p:style>
+          <a:lnRef idx="0"/>
+          <a:fillRef idx="0"/>
+          <a:effectRef idx="0"/>
+          <a:fontRef idx="minor"/>
+        </p:style>
+        <p:txBody>
+          <a:bodyPr lIns="90000" rIns="90000" tIns="-12960" bIns="-12960" anchor="t">
+            <a:noAutofit/>
+          </a:bodyPr>
+          <a:p>
+            <a:endParaRPr b="0" lang="en-US" sz="1800" strike="noStrike" u="none">
+              <a:solidFill>
+                <a:srgbClr val="ffffff"/>
+              </a:solidFill>
+              <a:effectLst/>
+              <a:uFillTx/>
+              <a:latin typeface="Arial"/>
+            </a:endParaRPr>
+          </a:p>
+        </p:txBody>
+      </p:sp>
+      <p:sp>
+        <p:nvSpPr>
+          <p:cNvPr id="185" name="Text 3"/>
+          <p:cNvSpPr/>
+          <p:nvPr/>
+        </p:nvSpPr>
+        <p:spPr>
+          <a:xfrm>
+            <a:off x="548640" y="6473880"/>
+            <a:ext cx="9143640" cy="200880"/>
+          </a:xfrm>
+          <a:prstGeom prst="rect">
+            <a:avLst/>
+          </a:prstGeom>
+          <a:noFill/>
+          <a:ln w="0">
+            <a:noFill/>
+          </a:ln>
+        </p:spPr>
+        <p:style>
+          <a:lnRef idx="0"/>
+          <a:fillRef idx="0"/>
+          <a:effectRef idx="0"/>
+          <a:fontRef idx="minor"/>
+        </p:style>
+        <p:txBody>
+          <a:bodyPr lIns="360" rIns="360" tIns="360" bIns="360" anchor="ctr">
+            <a:normAutofit/>
+          </a:bodyPr>
+          <a:p>
+            <a:pPr defTabSz="914400">
+              <a:lnSpc>
+                <a:spcPct val="100000"/>
+              </a:lnSpc>
+              <a:tabLst>
+                <a:tab algn="l" pos="0"/>
+              </a:tabLst>
+            </a:pPr>
+            <a:r>
+              <a:rPr b="0" lang="en-US" sz="900" strike="noStrike" u="none">
+                <a:solidFill>
+                  <a:srgbClr val="586a79"/>
+                </a:solidFill>
+                <a:effectLst/>
+                <a:uFillTx/>
+                <a:latin typeface="Aptos"/>
+                <a:ea typeface="Aptos"/>
+              </a:rPr>
+              <a:t>6G-DALI  ×  NATWORK  |  LOCAL CYBERSECURITY HACKATHON</a:t>
+            </a:r>
+            <a:endParaRPr b="0" lang="en-US" sz="900" strike="noStrike" u="none">
+              <a:solidFill>
+                <a:srgbClr val="000000"/>
+              </a:solidFill>
+              <a:effectLst/>
+              <a:uFillTx/>
+              <a:latin typeface="Arial"/>
+            </a:endParaRPr>
+          </a:p>
+        </p:txBody>
+      </p:sp>
+      <p:sp>
+        <p:nvSpPr>
+          <p:cNvPr id="186" name="Text 4"/>
+          <p:cNvSpPr/>
+          <p:nvPr/>
+        </p:nvSpPr>
+        <p:spPr>
+          <a:xfrm>
+            <a:off x="11018520" y="6473880"/>
+            <a:ext cx="511560" cy="200880"/>
+          </a:xfrm>
+          <a:prstGeom prst="rect">
+            <a:avLst/>
+          </a:prstGeom>
+          <a:noFill/>
+          <a:ln w="0">
+            <a:noFill/>
+          </a:ln>
+        </p:spPr>
+        <p:style>
+          <a:lnRef idx="0"/>
+          <a:fillRef idx="0"/>
+          <a:effectRef idx="0"/>
+          <a:fontRef idx="minor"/>
+        </p:style>
+        <p:txBody>
+          <a:bodyPr lIns="360" rIns="360" tIns="360" bIns="360" anchor="ctr">
+            <a:normAutofit/>
+          </a:bodyPr>
+          <a:p>
+            <a:pPr algn="r" defTabSz="914400">
+              <a:lnSpc>
+                <a:spcPct val="100000"/>
+              </a:lnSpc>
+              <a:tabLst>
+                <a:tab algn="l" pos="0"/>
+              </a:tabLst>
+            </a:pPr>
+            <a:r>
+              <a:rPr b="0" lang="en-US" sz="900" strike="noStrike" u="none">
+                <a:solidFill>
+                  <a:srgbClr val="586a79"/>
+                </a:solidFill>
+                <a:effectLst/>
+                <a:uFillTx/>
+                <a:latin typeface="Aptos"/>
+                <a:ea typeface="Aptos"/>
+              </a:rPr>
+              <a:t>13</a:t>
+            </a:r>
+            <a:endParaRPr b="0" lang="en-US" sz="900" strike="noStrike" u="none">
+              <a:solidFill>
+                <a:srgbClr val="000000"/>
+              </a:solidFill>
+              <a:effectLst/>
+              <a:uFillTx/>
+              <a:latin typeface="Arial"/>
+            </a:endParaRPr>
+          </a:p>
+        </p:txBody>
+      </p:sp>
+      <p:sp>
+        <p:nvSpPr>
+          <p:cNvPr id="187" name="Shape 5"/>
+          <p:cNvSpPr/>
+          <p:nvPr/>
+        </p:nvSpPr>
+        <p:spPr>
+          <a:xfrm>
+            <a:off x="786240" y="1454040"/>
+            <a:ext cx="77400" cy="77400"/>
+          </a:xfrm>
+          <a:prstGeom prst="roundRect">
+            <a:avLst>
+              <a:gd name="adj" fmla="val 117647"/>
+            </a:avLst>
+          </a:prstGeom>
+          <a:solidFill>
+            <a:srgbClr val="ee791f"/>
+          </a:solidFill>
+          <a:ln w="12700">
+            <a:solidFill>
+              <a:srgbClr val="ee791f"/>
+            </a:solidFill>
+            <a:round/>
+          </a:ln>
+        </p:spPr>
+        <p:style>
+          <a:lnRef idx="0"/>
+          <a:fillRef idx="0"/>
+          <a:effectRef idx="0"/>
+          <a:fontRef idx="minor"/>
+        </p:style>
+        <p:txBody>
+          <a:bodyPr lIns="90000" rIns="90000" tIns="10080" bIns="10080" anchor="t">
+            <a:noAutofit/>
+          </a:bodyPr>
+          <a:p>
+            <a:endParaRPr b="0" lang="en-US" sz="1800" strike="noStrike" u="none">
+              <a:solidFill>
+                <a:srgbClr val="ffffff"/>
+              </a:solidFill>
+              <a:effectLst/>
+              <a:uFillTx/>
+              <a:latin typeface="Arial"/>
+            </a:endParaRPr>
+          </a:p>
+        </p:txBody>
+      </p:sp>
+      <p:sp>
+        <p:nvSpPr>
+          <p:cNvPr id="188" name="Text 6"/>
+          <p:cNvSpPr/>
+          <p:nvPr/>
+        </p:nvSpPr>
+        <p:spPr>
+          <a:xfrm>
+            <a:off x="1033200" y="1334880"/>
+            <a:ext cx="10305000" cy="456840"/>
+          </a:xfrm>
+          <a:prstGeom prst="rect">
+            <a:avLst/>
+          </a:prstGeom>
+          <a:noFill/>
+          <a:ln w="0">
+            <a:noFill/>
+          </a:ln>
+        </p:spPr>
+        <p:style>
+          <a:lnRef idx="0"/>
+          <a:fillRef idx="0"/>
+          <a:effectRef idx="0"/>
+          <a:fontRef idx="minor"/>
+        </p:style>
+        <p:txBody>
+          <a:bodyPr lIns="360" rIns="360" tIns="360" bIns="360" anchor="ctr">
+            <a:normAutofit/>
+          </a:bodyPr>
+          <a:p>
+            <a:pPr defTabSz="914400">
+              <a:lnSpc>
+                <a:spcPct val="100000"/>
+              </a:lnSpc>
+              <a:tabLst>
+                <a:tab algn="l" pos="0"/>
+              </a:tabLst>
+            </a:pPr>
+            <a:r>
+              <a:rPr b="0" lang="en-US" sz="1800" strike="noStrike" u="none">
+                <a:solidFill>
+                  <a:srgbClr val="11233b"/>
+                </a:solidFill>
+                <a:effectLst/>
+                <a:uFillTx/>
+                <a:latin typeface="Aptos"/>
+                <a:ea typeface="Aptos"/>
+              </a:rPr>
+              <a:t>Shipped CNN (global-window head): FP 55.7%  ·  FN 36.7%  — far above the 1% KPI</a:t>
+            </a:r>
+            <a:endParaRPr b="0" lang="en-US" sz="1800" strike="noStrike" u="none">
+              <a:solidFill>
+                <a:srgbClr val="000000"/>
+              </a:solidFill>
+              <a:effectLst/>
+              <a:uFillTx/>
+              <a:latin typeface="Arial"/>
+            </a:endParaRPr>
+          </a:p>
+        </p:txBody>
+      </p:sp>
+      <p:sp>
+        <p:nvSpPr>
+          <p:cNvPr id="189" name="Shape 7"/>
+          <p:cNvSpPr/>
+          <p:nvPr/>
+        </p:nvSpPr>
+        <p:spPr>
+          <a:xfrm>
+            <a:off x="786240" y="2286000"/>
+            <a:ext cx="77400" cy="77400"/>
+          </a:xfrm>
+          <a:prstGeom prst="roundRect">
+            <a:avLst>
+              <a:gd name="adj" fmla="val 117647"/>
+            </a:avLst>
+          </a:prstGeom>
+          <a:solidFill>
+            <a:srgbClr val="ee791f"/>
+          </a:solidFill>
+          <a:ln w="12700">
+            <a:solidFill>
+              <a:srgbClr val="ee791f"/>
+            </a:solidFill>
+            <a:round/>
+          </a:ln>
+        </p:spPr>
+        <p:style>
+          <a:lnRef idx="0"/>
+          <a:fillRef idx="0"/>
+          <a:effectRef idx="0"/>
+          <a:fontRef idx="minor"/>
+        </p:style>
+        <p:txBody>
+          <a:bodyPr lIns="90000" rIns="90000" tIns="10080" bIns="10080" anchor="t">
+            <a:noAutofit/>
+          </a:bodyPr>
+          <a:p>
+            <a:endParaRPr b="0" lang="en-US" sz="1800" strike="noStrike" u="none">
+              <a:solidFill>
+                <a:srgbClr val="ffffff"/>
+              </a:solidFill>
+              <a:effectLst/>
+              <a:uFillTx/>
+              <a:latin typeface="Arial"/>
+            </a:endParaRPr>
+          </a:p>
+        </p:txBody>
+      </p:sp>
+      <p:sp>
+        <p:nvSpPr>
+          <p:cNvPr id="190" name="Text 8"/>
+          <p:cNvSpPr/>
+          <p:nvPr/>
+        </p:nvSpPr>
+        <p:spPr>
+          <a:xfrm>
+            <a:off x="1033200" y="2167200"/>
+            <a:ext cx="10305000" cy="456840"/>
+          </a:xfrm>
+          <a:prstGeom prst="rect">
+            <a:avLst/>
+          </a:prstGeom>
+          <a:noFill/>
+          <a:ln w="0">
+            <a:noFill/>
+          </a:ln>
+        </p:spPr>
+        <p:style>
+          <a:lnRef idx="0"/>
+          <a:fillRef idx="0"/>
+          <a:effectRef idx="0"/>
+          <a:fontRef idx="minor"/>
+        </p:style>
+        <p:txBody>
+          <a:bodyPr lIns="360" rIns="360" tIns="360" bIns="360" anchor="ctr">
+            <a:normAutofit/>
+          </a:bodyPr>
+          <a:p>
+            <a:pPr defTabSz="914400">
+              <a:lnSpc>
+                <a:spcPct val="100000"/>
+              </a:lnSpc>
+              <a:tabLst>
+                <a:tab algn="l" pos="0"/>
+              </a:tabLst>
+            </a:pPr>
+            <a:r>
+              <a:rPr b="0" lang="en-US" sz="1800" strike="noStrike" u="none">
+                <a:solidFill>
+                  <a:srgbClr val="11233b"/>
+                </a:solidFill>
+                <a:effectLst/>
+                <a:uFillTx/>
+                <a:latin typeface="Aptos"/>
+                <a:ea typeface="Aptos"/>
+              </a:rPr>
+              <a:t>Same architecture retrained on the new data: FP 38.0%  ·  FN 62.0%  — still fails</a:t>
+            </a:r>
+            <a:endParaRPr b="0" lang="en-US" sz="1800" strike="noStrike" u="none">
+              <a:solidFill>
+                <a:srgbClr val="000000"/>
+              </a:solidFill>
+              <a:effectLst/>
+              <a:uFillTx/>
+              <a:latin typeface="Arial"/>
+            </a:endParaRPr>
+          </a:p>
+        </p:txBody>
+      </p:sp>
+      <p:sp>
+        <p:nvSpPr>
+          <p:cNvPr id="191" name="Shape 9"/>
+          <p:cNvSpPr/>
+          <p:nvPr/>
+        </p:nvSpPr>
+        <p:spPr>
+          <a:xfrm>
+            <a:off x="786240" y="3117960"/>
+            <a:ext cx="77400" cy="77400"/>
+          </a:xfrm>
+          <a:prstGeom prst="roundRect">
+            <a:avLst>
+              <a:gd name="adj" fmla="val 117647"/>
+            </a:avLst>
+          </a:prstGeom>
+          <a:solidFill>
+            <a:srgbClr val="ee791f"/>
+          </a:solidFill>
+          <a:ln w="12700">
+            <a:solidFill>
+              <a:srgbClr val="ee791f"/>
+            </a:solidFill>
+            <a:round/>
+          </a:ln>
+        </p:spPr>
+        <p:style>
+          <a:lnRef idx="0"/>
+          <a:fillRef idx="0"/>
+          <a:effectRef idx="0"/>
+          <a:fontRef idx="minor"/>
+        </p:style>
+        <p:txBody>
+          <a:bodyPr lIns="90000" rIns="90000" tIns="10080" bIns="10080" anchor="t">
+            <a:noAutofit/>
+          </a:bodyPr>
+          <a:p>
+            <a:endParaRPr b="0" lang="en-US" sz="1800" strike="noStrike" u="none">
+              <a:solidFill>
+                <a:srgbClr val="ffffff"/>
+              </a:solidFill>
+              <a:effectLst/>
+              <a:uFillTx/>
+              <a:latin typeface="Arial"/>
+            </a:endParaRPr>
+          </a:p>
+        </p:txBody>
+      </p:sp>
+      <p:sp>
+        <p:nvSpPr>
+          <p:cNvPr id="192" name="Text 10"/>
+          <p:cNvSpPr/>
+          <p:nvPr/>
+        </p:nvSpPr>
+        <p:spPr>
+          <a:xfrm>
+            <a:off x="1033200" y="2999160"/>
+            <a:ext cx="10305000" cy="456840"/>
+          </a:xfrm>
+          <a:prstGeom prst="rect">
+            <a:avLst/>
+          </a:prstGeom>
+          <a:noFill/>
+          <a:ln w="0">
+            <a:noFill/>
+          </a:ln>
+        </p:spPr>
+        <p:style>
+          <a:lnRef idx="0"/>
+          <a:fillRef idx="0"/>
+          <a:effectRef idx="0"/>
+          <a:fontRef idx="minor"/>
+        </p:style>
+        <p:txBody>
+          <a:bodyPr lIns="360" rIns="360" tIns="360" bIns="360" anchor="ctr">
+            <a:normAutofit/>
+          </a:bodyPr>
+          <a:p>
+            <a:pPr defTabSz="914400">
+              <a:lnSpc>
+                <a:spcPct val="100000"/>
+              </a:lnSpc>
+              <a:tabLst>
+                <a:tab algn="l" pos="0"/>
+              </a:tabLst>
+            </a:pPr>
+            <a:r>
+              <a:rPr b="0" lang="en-US" sz="1800" strike="noStrike" u="none">
+                <a:solidFill>
+                  <a:srgbClr val="11233b"/>
+                </a:solidFill>
+                <a:effectLst/>
+                <a:uFillTx/>
+                <a:latin typeface="Aptos"/>
+                <a:ea typeface="Aptos"/>
+              </a:rPr>
+              <a:t>New per-packet CNN: FP 0.0001% (3 / 4.2M)  ·  FN 0.009% (162 / 1.8M)  — PASS</a:t>
+            </a:r>
+            <a:endParaRPr b="0" lang="en-US" sz="1800" strike="noStrike" u="none">
+              <a:solidFill>
+                <a:srgbClr val="000000"/>
+              </a:solidFill>
+              <a:effectLst/>
+              <a:uFillTx/>
+              <a:latin typeface="Arial"/>
+            </a:endParaRPr>
+          </a:p>
+        </p:txBody>
+      </p:sp>
+      <p:sp>
+        <p:nvSpPr>
+          <p:cNvPr id="193" name="Shape 11"/>
+          <p:cNvSpPr/>
+          <p:nvPr/>
+        </p:nvSpPr>
+        <p:spPr>
+          <a:xfrm>
+            <a:off x="786240" y="3950280"/>
+            <a:ext cx="77400" cy="77400"/>
+          </a:xfrm>
+          <a:prstGeom prst="roundRect">
+            <a:avLst>
+              <a:gd name="adj" fmla="val 117647"/>
+            </a:avLst>
+          </a:prstGeom>
+          <a:solidFill>
+            <a:srgbClr val="ee791f"/>
+          </a:solidFill>
+          <a:ln w="12700">
+            <a:solidFill>
+              <a:srgbClr val="ee791f"/>
+            </a:solidFill>
+            <a:round/>
+          </a:ln>
+        </p:spPr>
+        <p:style>
+          <a:lnRef idx="0"/>
+          <a:fillRef idx="0"/>
+          <a:effectRef idx="0"/>
+          <a:fontRef idx="minor"/>
+        </p:style>
+        <p:txBody>
+          <a:bodyPr lIns="90000" rIns="90000" tIns="10080" bIns="10080" anchor="t">
+            <a:noAutofit/>
+          </a:bodyPr>
+          <a:p>
+            <a:endParaRPr b="0" lang="en-US" sz="1800" strike="noStrike" u="none">
+              <a:solidFill>
+                <a:srgbClr val="ffffff"/>
+              </a:solidFill>
+              <a:effectLst/>
+              <a:uFillTx/>
+              <a:latin typeface="Arial"/>
+            </a:endParaRPr>
+          </a:p>
+        </p:txBody>
+      </p:sp>
+      <p:sp>
+        <p:nvSpPr>
+          <p:cNvPr id="194" name="Text 12"/>
+          <p:cNvSpPr/>
+          <p:nvPr/>
+        </p:nvSpPr>
+        <p:spPr>
+          <a:xfrm>
+            <a:off x="1033200" y="3831480"/>
+            <a:ext cx="10305000" cy="456840"/>
+          </a:xfrm>
+          <a:prstGeom prst="rect">
+            <a:avLst/>
+          </a:prstGeom>
+          <a:noFill/>
+          <a:ln w="0">
+            <a:noFill/>
+          </a:ln>
+        </p:spPr>
+        <p:style>
+          <a:lnRef idx="0"/>
+          <a:fillRef idx="0"/>
+          <a:effectRef idx="0"/>
+          <a:fontRef idx="minor"/>
+        </p:style>
+        <p:txBody>
+          <a:bodyPr lIns="360" rIns="360" tIns="360" bIns="360" anchor="ctr">
+            <a:normAutofit/>
+          </a:bodyPr>
+          <a:p>
+            <a:pPr defTabSz="914400">
+              <a:lnSpc>
+                <a:spcPct val="100000"/>
+              </a:lnSpc>
+              <a:tabLst>
+                <a:tab algn="l" pos="0"/>
+              </a:tabLst>
+            </a:pPr>
+            <a:r>
+              <a:rPr b="0" lang="en-US" sz="1800" strike="noStrike" u="none">
+                <a:solidFill>
+                  <a:srgbClr val="11233b"/>
+                </a:solidFill>
+                <a:effectLst/>
+                <a:uFillTx/>
+                <a:latin typeface="Aptos"/>
+                <a:ea typeface="Aptos"/>
+              </a:rPr>
+              <a:t>Same 100-packet window I/O; the per-packet head is ~17× smaller (38k vs 671k params)</a:t>
+            </a:r>
+            <a:endParaRPr b="0" lang="en-US" sz="1800" strike="noStrike" u="none">
+              <a:solidFill>
+                <a:srgbClr val="000000"/>
+              </a:solidFill>
+              <a:effectLst/>
+              <a:uFillTx/>
+              <a:latin typeface="Arial"/>
+            </a:endParaRPr>
+          </a:p>
+        </p:txBody>
+      </p:sp>
+      <p:sp>
+        <p:nvSpPr>
+          <p:cNvPr id="195" name="Shape 13"/>
+          <p:cNvSpPr/>
+          <p:nvPr/>
+        </p:nvSpPr>
+        <p:spPr>
+          <a:xfrm>
+            <a:off x="713160" y="5230440"/>
+            <a:ext cx="10789560" cy="667080"/>
+          </a:xfrm>
+          <a:prstGeom prst="roundRect">
+            <a:avLst>
+              <a:gd name="adj" fmla="val 13699"/>
+            </a:avLst>
+          </a:prstGeom>
+          <a:solidFill>
+            <a:srgbClr val="fff1e8"/>
+          </a:solidFill>
+          <a:ln w="12700">
+            <a:solidFill>
+              <a:srgbClr val="fff1e8"/>
+            </a:solidFill>
+            <a:round/>
+          </a:ln>
+        </p:spPr>
+        <p:style>
+          <a:lnRef idx="0"/>
+          <a:fillRef idx="0"/>
+          <a:effectRef idx="0"/>
+          <a:fontRef idx="minor"/>
+        </p:style>
+        <p:txBody>
+          <a:bodyPr lIns="90000" rIns="90000" tIns="45000" bIns="45000" anchor="t">
+            <a:noAutofit/>
+          </a:bodyPr>
+          <a:p>
+            <a:endParaRPr b="0" lang="en-US" sz="1800" strike="noStrike" u="none">
+              <a:solidFill>
+                <a:srgbClr val="000000"/>
+              </a:solidFill>
+              <a:effectLst/>
+              <a:uFillTx/>
+              <a:latin typeface="Arial"/>
+            </a:endParaRPr>
+          </a:p>
+        </p:txBody>
+      </p:sp>
+      <p:sp>
+        <p:nvSpPr>
+          <p:cNvPr id="196" name="Text 14"/>
+          <p:cNvSpPr/>
+          <p:nvPr/>
+        </p:nvSpPr>
+        <p:spPr>
+          <a:xfrm>
+            <a:off x="923400" y="5330880"/>
+            <a:ext cx="10323360" cy="465840"/>
+          </a:xfrm>
+          <a:prstGeom prst="rect">
+            <a:avLst/>
+          </a:prstGeom>
+          <a:noFill/>
+          <a:ln w="0">
+            <a:noFill/>
+          </a:ln>
+        </p:spPr>
+        <p:style>
+          <a:lnRef idx="0"/>
+          <a:fillRef idx="0"/>
+          <a:effectRef idx="0"/>
+          <a:fontRef idx="minor"/>
+        </p:style>
+        <p:txBody>
+          <a:bodyPr lIns="360" rIns="360" tIns="360" bIns="360" anchor="ctr">
+            <a:normAutofit lnSpcReduction="9999"/>
+          </a:bodyPr>
+          <a:p>
+            <a:pPr defTabSz="914400">
+              <a:lnSpc>
+                <a:spcPct val="100000"/>
+              </a:lnSpc>
+              <a:tabLst>
+                <a:tab algn="l" pos="0"/>
+              </a:tabLst>
+            </a:pPr>
+            <a:r>
+              <a:rPr b="1" lang="en-US" sz="1600" strike="noStrike" u="none">
+                <a:solidFill>
+                  <a:srgbClr val="8a4c26"/>
+                </a:solidFill>
+                <a:effectLst/>
+                <a:uFillTx/>
+                <a:latin typeface="Aptos"/>
+                <a:ea typeface="Aptos"/>
+              </a:rPr>
+              <a:t>NATWORK KPIs met: false positives &lt; 1% and false negatives &lt; 1%, by three orders of magnitude — on real interleaved traffic with randomized addresses. Packaged as best_run_perpacket.zip.</a:t>
+            </a:r>
+            <a:endParaRPr b="0" lang="en-US" sz="1600" strike="noStrike" u="none">
               <a:solidFill>
                 <a:srgbClr val="000000"/>
               </a:solidFill>

</xml_diff>